<commit_message>
fp16 image tensor generation, docs
</commit_message>
<xml_diff>
--- a/docs/helper-slides.pptx
+++ b/docs/helper-slides.pptx
@@ -6,6 +6,10 @@
   </p:sldMasterIdLst>
   <p:sldIdLst>
     <p:sldId id="256" r:id="rId2"/>
+    <p:sldId id="257" r:id="rId3"/>
+    <p:sldId id="258" r:id="rId4"/>
+    <p:sldId id="259" r:id="rId5"/>
+    <p:sldId id="260" r:id="rId6"/>
   </p:sldIdLst>
   <p:sldSz cx="12192000" cy="6858000"/>
   <p:notesSz cx="6858000" cy="9144000"/>
@@ -104,6 +108,11 @@
       </a:defRPr>
     </a:lvl9pPr>
   </p:defaultTextStyle>
+  <p:extLst>
+    <p:ext uri="{EFAFB233-063F-42B5-8137-9DF3F51BA10A}">
+      <p15:sldGuideLst xmlns:p15="http://schemas.microsoft.com/office/powerpoint/2012/main"/>
+    </p:ext>
+  </p:extLst>
 </p:presentation>
 </file>
 
@@ -4105,6 +4114,3950 @@
     <p:extLst>
       <p:ext uri="{BB962C8B-B14F-4D97-AF65-F5344CB8AC3E}">
         <p14:creationId xmlns:p14="http://schemas.microsoft.com/office/powerpoint/2010/main" val="317719029"/>
+      </p:ext>
+    </p:extLst>
+  </p:cSld>
+  <p:clrMapOvr>
+    <a:masterClrMapping/>
+  </p:clrMapOvr>
+</p:sld>
+</file>
+
+<file path=ppt/slides/slide2.xml><?xml version="1.0" encoding="utf-8"?>
+<p:sld xmlns:a="http://schemas.openxmlformats.org/drawingml/2006/main" xmlns:r="http://schemas.openxmlformats.org/officeDocument/2006/relationships" xmlns:p="http://schemas.openxmlformats.org/presentationml/2006/main">
+  <p:cSld>
+    <p:spTree>
+      <p:nvGrpSpPr>
+        <p:cNvPr id="1" name=""/>
+        <p:cNvGrpSpPr/>
+        <p:nvPr/>
+      </p:nvGrpSpPr>
+      <p:grpSpPr>
+        <a:xfrm>
+          <a:off x="0" y="0"/>
+          <a:ext cx="0" cy="0"/>
+          <a:chOff x="0" y="0"/>
+          <a:chExt cx="0" cy="0"/>
+        </a:xfrm>
+      </p:grpSpPr>
+      <p:sp>
+        <p:nvSpPr>
+          <p:cNvPr id="4" name="Rounded Rectangle 3">
+            <a:extLst>
+              <a:ext uri="{FF2B5EF4-FFF2-40B4-BE49-F238E27FC236}">
+                <a16:creationId xmlns:a16="http://schemas.microsoft.com/office/drawing/2014/main" id="{90B2C630-BBEA-6ECC-F808-AF3E87882CAD}"/>
+              </a:ext>
+            </a:extLst>
+          </p:cNvPr>
+          <p:cNvSpPr/>
+          <p:nvPr/>
+        </p:nvSpPr>
+        <p:spPr>
+          <a:xfrm>
+            <a:off x="172300" y="782893"/>
+            <a:ext cx="1713611" cy="965922"/>
+          </a:xfrm>
+          <a:prstGeom prst="roundRect">
+            <a:avLst/>
+          </a:prstGeom>
+        </p:spPr>
+        <p:style>
+          <a:lnRef idx="2">
+            <a:schemeClr val="accent1">
+              <a:shade val="15000"/>
+            </a:schemeClr>
+          </a:lnRef>
+          <a:fillRef idx="1">
+            <a:schemeClr val="accent1"/>
+          </a:fillRef>
+          <a:effectRef idx="0">
+            <a:schemeClr val="accent1"/>
+          </a:effectRef>
+          <a:fontRef idx="minor">
+            <a:schemeClr val="lt1"/>
+          </a:fontRef>
+        </p:style>
+        <p:txBody>
+          <a:bodyPr rtlCol="0" anchor="ctr"/>
+          <a:lstStyle/>
+          <a:p>
+            <a:pPr algn="ctr"/>
+            <a:r>
+              <a:rPr lang="en-HU" b="1" dirty="0"/>
+              <a:t>Video source</a:t>
+            </a:r>
+          </a:p>
+        </p:txBody>
+      </p:sp>
+      <p:cxnSp>
+        <p:nvCxnSpPr>
+          <p:cNvPr id="5" name="Straight Arrow Connector 4">
+            <a:extLst>
+              <a:ext uri="{FF2B5EF4-FFF2-40B4-BE49-F238E27FC236}">
+                <a16:creationId xmlns:a16="http://schemas.microsoft.com/office/drawing/2014/main" id="{E6A012D0-0E36-2618-7F0F-87F3741D67FB}"/>
+              </a:ext>
+            </a:extLst>
+          </p:cNvPr>
+          <p:cNvCxnSpPr>
+            <a:cxnSpLocks/>
+            <a:endCxn id="6" idx="1"/>
+          </p:cNvCxnSpPr>
+          <p:nvPr/>
+        </p:nvCxnSpPr>
+        <p:spPr>
+          <a:xfrm>
+            <a:off x="1885911" y="1265854"/>
+            <a:ext cx="263523" cy="0"/>
+          </a:xfrm>
+          <a:prstGeom prst="straightConnector1">
+            <a:avLst/>
+          </a:prstGeom>
+          <a:ln>
+            <a:tailEnd type="triangle"/>
+          </a:ln>
+        </p:spPr>
+        <p:style>
+          <a:lnRef idx="3">
+            <a:schemeClr val="dk1"/>
+          </a:lnRef>
+          <a:fillRef idx="0">
+            <a:schemeClr val="dk1"/>
+          </a:fillRef>
+          <a:effectRef idx="2">
+            <a:schemeClr val="dk1"/>
+          </a:effectRef>
+          <a:fontRef idx="minor">
+            <a:schemeClr val="tx1"/>
+          </a:fontRef>
+        </p:style>
+      </p:cxnSp>
+      <p:sp>
+        <p:nvSpPr>
+          <p:cNvPr id="6" name="Rounded Rectangle 5">
+            <a:extLst>
+              <a:ext uri="{FF2B5EF4-FFF2-40B4-BE49-F238E27FC236}">
+                <a16:creationId xmlns:a16="http://schemas.microsoft.com/office/drawing/2014/main" id="{194C01EC-1459-DC50-C01A-9CEF1A6FE857}"/>
+              </a:ext>
+            </a:extLst>
+          </p:cNvPr>
+          <p:cNvSpPr/>
+          <p:nvPr/>
+        </p:nvSpPr>
+        <p:spPr>
+          <a:xfrm>
+            <a:off x="2149434" y="782893"/>
+            <a:ext cx="1713611" cy="965922"/>
+          </a:xfrm>
+          <a:prstGeom prst="roundRect">
+            <a:avLst/>
+          </a:prstGeom>
+        </p:spPr>
+        <p:style>
+          <a:lnRef idx="2">
+            <a:schemeClr val="accent1">
+              <a:shade val="15000"/>
+            </a:schemeClr>
+          </a:lnRef>
+          <a:fillRef idx="1">
+            <a:schemeClr val="accent1"/>
+          </a:fillRef>
+          <a:effectRef idx="0">
+            <a:schemeClr val="accent1"/>
+          </a:effectRef>
+          <a:fontRef idx="minor">
+            <a:schemeClr val="lt1"/>
+          </a:fontRef>
+        </p:style>
+        <p:txBody>
+          <a:bodyPr rtlCol="0" anchor="ctr"/>
+          <a:lstStyle/>
+          <a:p>
+            <a:pPr algn="ctr"/>
+            <a:r>
+              <a:rPr lang="en-HU" b="1" dirty="0"/>
+              <a:t>Yolo object detector inference</a:t>
+            </a:r>
+          </a:p>
+        </p:txBody>
+      </p:sp>
+      <p:sp>
+        <p:nvSpPr>
+          <p:cNvPr id="7" name="Rounded Rectangle 6">
+            <a:extLst>
+              <a:ext uri="{FF2B5EF4-FFF2-40B4-BE49-F238E27FC236}">
+                <a16:creationId xmlns:a16="http://schemas.microsoft.com/office/drawing/2014/main" id="{12288202-E4E0-AD47-E375-BB6710AA7DA1}"/>
+              </a:ext>
+            </a:extLst>
+          </p:cNvPr>
+          <p:cNvSpPr/>
+          <p:nvPr/>
+        </p:nvSpPr>
+        <p:spPr>
+          <a:xfrm>
+            <a:off x="2142976" y="2542363"/>
+            <a:ext cx="1713611" cy="1756590"/>
+          </a:xfrm>
+          <a:prstGeom prst="roundRect">
+            <a:avLst/>
+          </a:prstGeom>
+          <a:solidFill>
+            <a:schemeClr val="accent4">
+              <a:lumMod val="60000"/>
+              <a:lumOff val="40000"/>
+            </a:schemeClr>
+          </a:solidFill>
+        </p:spPr>
+        <p:style>
+          <a:lnRef idx="2">
+            <a:schemeClr val="accent1">
+              <a:shade val="15000"/>
+            </a:schemeClr>
+          </a:lnRef>
+          <a:fillRef idx="1">
+            <a:schemeClr val="accent1"/>
+          </a:fillRef>
+          <a:effectRef idx="0">
+            <a:schemeClr val="accent1"/>
+          </a:effectRef>
+          <a:fontRef idx="minor">
+            <a:schemeClr val="lt1"/>
+          </a:fontRef>
+        </p:style>
+        <p:txBody>
+          <a:bodyPr rtlCol="0" anchor="ctr"/>
+          <a:lstStyle/>
+          <a:p>
+            <a:pPr algn="ctr"/>
+            <a:r>
+              <a:rPr lang="en-HU" sz="1200" b="1" dirty="0"/>
+              <a:t>Perception</a:t>
+            </a:r>
+          </a:p>
+          <a:p>
+            <a:pPr algn="ctr"/>
+            <a:r>
+              <a:rPr lang="en-HU" sz="1200" b="1" dirty="0"/>
+              <a:t>Context attachments:</a:t>
+            </a:r>
+          </a:p>
+          <a:p>
+            <a:pPr algn="ctr"/>
+            <a:endParaRPr lang="en-HU" sz="1200" b="1" dirty="0"/>
+          </a:p>
+          <a:p>
+            <a:pPr algn="ctr"/>
+            <a:r>
+              <a:rPr lang="en-GB" sz="1600" b="1" dirty="0"/>
+              <a:t>O</a:t>
+            </a:r>
+            <a:r>
+              <a:rPr lang="en-HU" sz="1600" b="1" dirty="0"/>
+              <a:t>bject rectangles and labels</a:t>
+            </a:r>
+            <a:endParaRPr lang="en-HU" sz="1200" b="1" dirty="0"/>
+          </a:p>
+        </p:txBody>
+      </p:sp>
+      <p:sp>
+        <p:nvSpPr>
+          <p:cNvPr id="8" name="Rounded Rectangle 7">
+            <a:extLst>
+              <a:ext uri="{FF2B5EF4-FFF2-40B4-BE49-F238E27FC236}">
+                <a16:creationId xmlns:a16="http://schemas.microsoft.com/office/drawing/2014/main" id="{24415999-F57B-3D04-6409-B3156B70CA59}"/>
+              </a:ext>
+            </a:extLst>
+          </p:cNvPr>
+          <p:cNvSpPr/>
+          <p:nvPr/>
+        </p:nvSpPr>
+        <p:spPr>
+          <a:xfrm>
+            <a:off x="4126568" y="782893"/>
+            <a:ext cx="1713611" cy="965922"/>
+          </a:xfrm>
+          <a:prstGeom prst="roundRect">
+            <a:avLst/>
+          </a:prstGeom>
+        </p:spPr>
+        <p:style>
+          <a:lnRef idx="2">
+            <a:schemeClr val="accent1">
+              <a:shade val="15000"/>
+            </a:schemeClr>
+          </a:lnRef>
+          <a:fillRef idx="1">
+            <a:schemeClr val="accent1"/>
+          </a:fillRef>
+          <a:effectRef idx="0">
+            <a:schemeClr val="accent1"/>
+          </a:effectRef>
+          <a:fontRef idx="minor">
+            <a:schemeClr val="lt1"/>
+          </a:fontRef>
+        </p:style>
+        <p:txBody>
+          <a:bodyPr rtlCol="0" anchor="ctr"/>
+          <a:lstStyle/>
+          <a:p>
+            <a:pPr algn="ctr"/>
+            <a:r>
+              <a:rPr lang="en-HU" b="1" dirty="0"/>
+              <a:t>UltraFace</a:t>
+            </a:r>
+          </a:p>
+          <a:p>
+            <a:pPr algn="ctr"/>
+            <a:r>
+              <a:rPr lang="en-GB" b="1" dirty="0"/>
+              <a:t>f</a:t>
+            </a:r>
+            <a:r>
+              <a:rPr lang="en-HU" b="1" dirty="0"/>
+              <a:t>ace detector inference</a:t>
+            </a:r>
+          </a:p>
+        </p:txBody>
+      </p:sp>
+      <p:cxnSp>
+        <p:nvCxnSpPr>
+          <p:cNvPr id="9" name="Straight Arrow Connector 8">
+            <a:extLst>
+              <a:ext uri="{FF2B5EF4-FFF2-40B4-BE49-F238E27FC236}">
+                <a16:creationId xmlns:a16="http://schemas.microsoft.com/office/drawing/2014/main" id="{4002AE7B-E083-8EC4-7558-F91079011B77}"/>
+              </a:ext>
+            </a:extLst>
+          </p:cNvPr>
+          <p:cNvCxnSpPr>
+            <a:cxnSpLocks/>
+            <a:stCxn id="6" idx="3"/>
+            <a:endCxn id="8" idx="1"/>
+          </p:cNvCxnSpPr>
+          <p:nvPr/>
+        </p:nvCxnSpPr>
+        <p:spPr>
+          <a:xfrm>
+            <a:off x="3863045" y="1265854"/>
+            <a:ext cx="263523" cy="0"/>
+          </a:xfrm>
+          <a:prstGeom prst="straightConnector1">
+            <a:avLst/>
+          </a:prstGeom>
+          <a:ln>
+            <a:tailEnd type="triangle"/>
+          </a:ln>
+        </p:spPr>
+        <p:style>
+          <a:lnRef idx="3">
+            <a:schemeClr val="dk1"/>
+          </a:lnRef>
+          <a:fillRef idx="0">
+            <a:schemeClr val="dk1"/>
+          </a:fillRef>
+          <a:effectRef idx="2">
+            <a:schemeClr val="dk1"/>
+          </a:effectRef>
+          <a:fontRef idx="minor">
+            <a:schemeClr val="tx1"/>
+          </a:fontRef>
+        </p:style>
+      </p:cxnSp>
+      <p:sp>
+        <p:nvSpPr>
+          <p:cNvPr id="10" name="Rounded Rectangle 9">
+            <a:extLst>
+              <a:ext uri="{FF2B5EF4-FFF2-40B4-BE49-F238E27FC236}">
+                <a16:creationId xmlns:a16="http://schemas.microsoft.com/office/drawing/2014/main" id="{2564983F-E18E-D92F-B369-D89C7B4AD6CD}"/>
+              </a:ext>
+            </a:extLst>
+          </p:cNvPr>
+          <p:cNvSpPr/>
+          <p:nvPr/>
+        </p:nvSpPr>
+        <p:spPr>
+          <a:xfrm>
+            <a:off x="4120110" y="2542360"/>
+            <a:ext cx="1713611" cy="2420477"/>
+          </a:xfrm>
+          <a:prstGeom prst="roundRect">
+            <a:avLst/>
+          </a:prstGeom>
+          <a:solidFill>
+            <a:schemeClr val="accent4">
+              <a:lumMod val="60000"/>
+              <a:lumOff val="40000"/>
+            </a:schemeClr>
+          </a:solidFill>
+        </p:spPr>
+        <p:style>
+          <a:lnRef idx="2">
+            <a:schemeClr val="accent1">
+              <a:shade val="15000"/>
+            </a:schemeClr>
+          </a:lnRef>
+          <a:fillRef idx="1">
+            <a:schemeClr val="accent1"/>
+          </a:fillRef>
+          <a:effectRef idx="0">
+            <a:schemeClr val="accent1"/>
+          </a:effectRef>
+          <a:fontRef idx="minor">
+            <a:schemeClr val="lt1"/>
+          </a:fontRef>
+        </p:style>
+        <p:txBody>
+          <a:bodyPr rtlCol="0" anchor="ctr"/>
+          <a:lstStyle/>
+          <a:p>
+            <a:pPr algn="ctr"/>
+            <a:r>
+              <a:rPr lang="en-HU" sz="1200" b="1" dirty="0"/>
+              <a:t>Perception</a:t>
+            </a:r>
+          </a:p>
+          <a:p>
+            <a:pPr algn="ctr"/>
+            <a:r>
+              <a:rPr lang="en-HU" sz="1200" b="1" dirty="0"/>
+              <a:t>Context attachments:</a:t>
+            </a:r>
+          </a:p>
+          <a:p>
+            <a:pPr algn="ctr"/>
+            <a:endParaRPr lang="en-HU" sz="1200" b="1" dirty="0"/>
+          </a:p>
+          <a:p>
+            <a:pPr algn="ctr"/>
+            <a:r>
+              <a:rPr lang="en-GB" sz="1600" b="1" dirty="0"/>
+              <a:t>O</a:t>
+            </a:r>
+            <a:r>
+              <a:rPr lang="en-HU" sz="1600" b="1" dirty="0"/>
+              <a:t>bject rectangles and labels</a:t>
+            </a:r>
+          </a:p>
+          <a:p>
+            <a:pPr algn="ctr"/>
+            <a:endParaRPr lang="en-HU" sz="1600" b="1" dirty="0"/>
+          </a:p>
+          <a:p>
+            <a:pPr algn="ctr"/>
+            <a:r>
+              <a:rPr lang="en-HU" sz="1600" b="1" dirty="0"/>
+              <a:t>Human face rectangles</a:t>
+            </a:r>
+            <a:endParaRPr lang="en-HU" sz="1200" b="1" dirty="0"/>
+          </a:p>
+        </p:txBody>
+      </p:sp>
+      <p:sp>
+        <p:nvSpPr>
+          <p:cNvPr id="11" name="Rounded Rectangle 10">
+            <a:extLst>
+              <a:ext uri="{FF2B5EF4-FFF2-40B4-BE49-F238E27FC236}">
+                <a16:creationId xmlns:a16="http://schemas.microsoft.com/office/drawing/2014/main" id="{98D79CBE-6DE2-51E5-78FA-CAAD9B44396F}"/>
+              </a:ext>
+            </a:extLst>
+          </p:cNvPr>
+          <p:cNvSpPr/>
+          <p:nvPr/>
+        </p:nvSpPr>
+        <p:spPr>
+          <a:xfrm>
+            <a:off x="8080836" y="770929"/>
+            <a:ext cx="1713611" cy="965922"/>
+          </a:xfrm>
+          <a:prstGeom prst="roundRect">
+            <a:avLst/>
+          </a:prstGeom>
+        </p:spPr>
+        <p:style>
+          <a:lnRef idx="2">
+            <a:schemeClr val="accent1">
+              <a:shade val="15000"/>
+            </a:schemeClr>
+          </a:lnRef>
+          <a:fillRef idx="1">
+            <a:schemeClr val="accent1"/>
+          </a:fillRef>
+          <a:effectRef idx="0">
+            <a:schemeClr val="accent1"/>
+          </a:effectRef>
+          <a:fontRef idx="minor">
+            <a:schemeClr val="lt1"/>
+          </a:fontRef>
+        </p:style>
+        <p:txBody>
+          <a:bodyPr rtlCol="0" anchor="ctr"/>
+          <a:lstStyle/>
+          <a:p>
+            <a:pPr algn="ctr"/>
+            <a:r>
+              <a:rPr lang="en-US" b="1" dirty="0"/>
+              <a:t>Face recognition inference</a:t>
+            </a:r>
+            <a:endParaRPr lang="en-HU" b="1" dirty="0"/>
+          </a:p>
+        </p:txBody>
+      </p:sp>
+      <p:cxnSp>
+        <p:nvCxnSpPr>
+          <p:cNvPr id="12" name="Straight Arrow Connector 11">
+            <a:extLst>
+              <a:ext uri="{FF2B5EF4-FFF2-40B4-BE49-F238E27FC236}">
+                <a16:creationId xmlns:a16="http://schemas.microsoft.com/office/drawing/2014/main" id="{D6344D7A-7588-B82E-5A0B-DC2AEFD3BFD9}"/>
+              </a:ext>
+            </a:extLst>
+          </p:cNvPr>
+          <p:cNvCxnSpPr>
+            <a:cxnSpLocks/>
+            <a:stCxn id="8" idx="3"/>
+            <a:endCxn id="14" idx="1"/>
+          </p:cNvCxnSpPr>
+          <p:nvPr/>
+        </p:nvCxnSpPr>
+        <p:spPr>
+          <a:xfrm>
+            <a:off x="5840179" y="1265854"/>
+            <a:ext cx="263523" cy="0"/>
+          </a:xfrm>
+          <a:prstGeom prst="straightConnector1">
+            <a:avLst/>
+          </a:prstGeom>
+          <a:ln>
+            <a:tailEnd type="triangle"/>
+          </a:ln>
+        </p:spPr>
+        <p:style>
+          <a:lnRef idx="3">
+            <a:schemeClr val="dk1"/>
+          </a:lnRef>
+          <a:fillRef idx="0">
+            <a:schemeClr val="dk1"/>
+          </a:fillRef>
+          <a:effectRef idx="2">
+            <a:schemeClr val="dk1"/>
+          </a:effectRef>
+          <a:fontRef idx="minor">
+            <a:schemeClr val="tx1"/>
+          </a:fontRef>
+        </p:style>
+      </p:cxnSp>
+      <p:sp>
+        <p:nvSpPr>
+          <p:cNvPr id="13" name="Rounded Rectangle 12">
+            <a:extLst>
+              <a:ext uri="{FF2B5EF4-FFF2-40B4-BE49-F238E27FC236}">
+                <a16:creationId xmlns:a16="http://schemas.microsoft.com/office/drawing/2014/main" id="{FB39E48C-26D7-F4C1-19CF-A5202577CE91}"/>
+              </a:ext>
+            </a:extLst>
+          </p:cNvPr>
+          <p:cNvSpPr/>
+          <p:nvPr/>
+        </p:nvSpPr>
+        <p:spPr>
+          <a:xfrm>
+            <a:off x="6097244" y="2542360"/>
+            <a:ext cx="1713611" cy="2991623"/>
+          </a:xfrm>
+          <a:prstGeom prst="roundRect">
+            <a:avLst/>
+          </a:prstGeom>
+          <a:solidFill>
+            <a:schemeClr val="accent4">
+              <a:lumMod val="60000"/>
+              <a:lumOff val="40000"/>
+            </a:schemeClr>
+          </a:solidFill>
+        </p:spPr>
+        <p:style>
+          <a:lnRef idx="2">
+            <a:schemeClr val="accent1">
+              <a:shade val="15000"/>
+            </a:schemeClr>
+          </a:lnRef>
+          <a:fillRef idx="1">
+            <a:schemeClr val="accent1"/>
+          </a:fillRef>
+          <a:effectRef idx="0">
+            <a:schemeClr val="accent1"/>
+          </a:effectRef>
+          <a:fontRef idx="minor">
+            <a:schemeClr val="lt1"/>
+          </a:fontRef>
+        </p:style>
+        <p:txBody>
+          <a:bodyPr rtlCol="0" anchor="ctr"/>
+          <a:lstStyle/>
+          <a:p>
+            <a:pPr algn="ctr"/>
+            <a:r>
+              <a:rPr lang="en-HU" sz="1200" b="1" dirty="0"/>
+              <a:t>Perception</a:t>
+            </a:r>
+          </a:p>
+          <a:p>
+            <a:pPr algn="ctr"/>
+            <a:r>
+              <a:rPr lang="en-HU" sz="1200" b="1" dirty="0"/>
+              <a:t>Context attachments:</a:t>
+            </a:r>
+          </a:p>
+          <a:p>
+            <a:pPr algn="ctr"/>
+            <a:endParaRPr lang="en-HU" sz="1200" b="1" dirty="0"/>
+          </a:p>
+          <a:p>
+            <a:pPr algn="ctr"/>
+            <a:r>
+              <a:rPr lang="en-GB" sz="1600" b="1" dirty="0"/>
+              <a:t>O</a:t>
+            </a:r>
+            <a:r>
+              <a:rPr lang="en-HU" sz="1600" b="1" dirty="0"/>
+              <a:t>bject rectangles and labels</a:t>
+            </a:r>
+          </a:p>
+          <a:p>
+            <a:pPr algn="ctr"/>
+            <a:endParaRPr lang="en-HU" sz="1600" b="1" dirty="0"/>
+          </a:p>
+          <a:p>
+            <a:pPr algn="ctr"/>
+            <a:r>
+              <a:rPr lang="en-HU" sz="1600" b="1" dirty="0"/>
+              <a:t>Human face rectangles</a:t>
+            </a:r>
+          </a:p>
+          <a:p>
+            <a:pPr algn="ctr"/>
+            <a:endParaRPr lang="en-HU" sz="1600" b="1" dirty="0"/>
+          </a:p>
+          <a:p>
+            <a:pPr algn="ctr"/>
+            <a:r>
+              <a:rPr lang="en-HU" sz="1600" b="1" dirty="0"/>
+              <a:t>EntityId</a:t>
+            </a:r>
+            <a:endParaRPr lang="en-HU" sz="1200" b="1" dirty="0"/>
+          </a:p>
+        </p:txBody>
+      </p:sp>
+      <p:sp>
+        <p:nvSpPr>
+          <p:cNvPr id="14" name="Rounded Rectangle 13">
+            <a:extLst>
+              <a:ext uri="{FF2B5EF4-FFF2-40B4-BE49-F238E27FC236}">
+                <a16:creationId xmlns:a16="http://schemas.microsoft.com/office/drawing/2014/main" id="{250A1078-1422-196B-B103-78D6C39EA443}"/>
+              </a:ext>
+            </a:extLst>
+          </p:cNvPr>
+          <p:cNvSpPr/>
+          <p:nvPr/>
+        </p:nvSpPr>
+        <p:spPr>
+          <a:xfrm>
+            <a:off x="6103702" y="782893"/>
+            <a:ext cx="1713611" cy="965922"/>
+          </a:xfrm>
+          <a:prstGeom prst="roundRect">
+            <a:avLst/>
+          </a:prstGeom>
+        </p:spPr>
+        <p:style>
+          <a:lnRef idx="2">
+            <a:schemeClr val="accent1">
+              <a:shade val="15000"/>
+            </a:schemeClr>
+          </a:lnRef>
+          <a:fillRef idx="1">
+            <a:schemeClr val="accent1"/>
+          </a:fillRef>
+          <a:effectRef idx="0">
+            <a:schemeClr val="accent1"/>
+          </a:effectRef>
+          <a:fontRef idx="minor">
+            <a:schemeClr val="lt1"/>
+          </a:fontRef>
+        </p:style>
+        <p:txBody>
+          <a:bodyPr rtlCol="0" anchor="ctr"/>
+          <a:lstStyle/>
+          <a:p>
+            <a:pPr algn="ctr"/>
+            <a:r>
+              <a:rPr lang="en-US" b="1" dirty="0"/>
+              <a:t>Tracker</a:t>
+            </a:r>
+            <a:endParaRPr lang="en-HU" b="1" dirty="0"/>
+          </a:p>
+        </p:txBody>
+      </p:sp>
+      <p:cxnSp>
+        <p:nvCxnSpPr>
+          <p:cNvPr id="15" name="Straight Arrow Connector 14">
+            <a:extLst>
+              <a:ext uri="{FF2B5EF4-FFF2-40B4-BE49-F238E27FC236}">
+                <a16:creationId xmlns:a16="http://schemas.microsoft.com/office/drawing/2014/main" id="{5C82BAE2-BAFD-F550-5BB0-8A668021093A}"/>
+              </a:ext>
+            </a:extLst>
+          </p:cNvPr>
+          <p:cNvCxnSpPr>
+            <a:cxnSpLocks/>
+          </p:cNvCxnSpPr>
+          <p:nvPr/>
+        </p:nvCxnSpPr>
+        <p:spPr>
+          <a:xfrm>
+            <a:off x="7812853" y="1282821"/>
+            <a:ext cx="263523" cy="0"/>
+          </a:xfrm>
+          <a:prstGeom prst="straightConnector1">
+            <a:avLst/>
+          </a:prstGeom>
+          <a:ln>
+            <a:tailEnd type="triangle"/>
+          </a:ln>
+        </p:spPr>
+        <p:style>
+          <a:lnRef idx="3">
+            <a:schemeClr val="dk1"/>
+          </a:lnRef>
+          <a:fillRef idx="0">
+            <a:schemeClr val="dk1"/>
+          </a:fillRef>
+          <a:effectRef idx="2">
+            <a:schemeClr val="dk1"/>
+          </a:effectRef>
+          <a:fontRef idx="minor">
+            <a:schemeClr val="tx1"/>
+          </a:fontRef>
+        </p:style>
+      </p:cxnSp>
+      <p:sp>
+        <p:nvSpPr>
+          <p:cNvPr id="16" name="Rounded Rectangle 15">
+            <a:extLst>
+              <a:ext uri="{FF2B5EF4-FFF2-40B4-BE49-F238E27FC236}">
+                <a16:creationId xmlns:a16="http://schemas.microsoft.com/office/drawing/2014/main" id="{759E8FC1-9D45-9274-7696-236A97D2119C}"/>
+              </a:ext>
+            </a:extLst>
+          </p:cNvPr>
+          <p:cNvSpPr/>
+          <p:nvPr/>
+        </p:nvSpPr>
+        <p:spPr>
+          <a:xfrm>
+            <a:off x="8074378" y="2466139"/>
+            <a:ext cx="1713611" cy="3495358"/>
+          </a:xfrm>
+          <a:prstGeom prst="roundRect">
+            <a:avLst/>
+          </a:prstGeom>
+          <a:solidFill>
+            <a:schemeClr val="accent4">
+              <a:lumMod val="60000"/>
+              <a:lumOff val="40000"/>
+            </a:schemeClr>
+          </a:solidFill>
+        </p:spPr>
+        <p:style>
+          <a:lnRef idx="2">
+            <a:schemeClr val="accent1">
+              <a:shade val="15000"/>
+            </a:schemeClr>
+          </a:lnRef>
+          <a:fillRef idx="1">
+            <a:schemeClr val="accent1"/>
+          </a:fillRef>
+          <a:effectRef idx="0">
+            <a:schemeClr val="accent1"/>
+          </a:effectRef>
+          <a:fontRef idx="minor">
+            <a:schemeClr val="lt1"/>
+          </a:fontRef>
+        </p:style>
+        <p:txBody>
+          <a:bodyPr rtlCol="0" anchor="ctr"/>
+          <a:lstStyle/>
+          <a:p>
+            <a:pPr algn="ctr"/>
+            <a:r>
+              <a:rPr lang="en-HU" sz="1200" b="1" dirty="0"/>
+              <a:t>Perception</a:t>
+            </a:r>
+          </a:p>
+          <a:p>
+            <a:pPr algn="ctr"/>
+            <a:r>
+              <a:rPr lang="en-HU" sz="1200" b="1" dirty="0"/>
+              <a:t>Context attachments:</a:t>
+            </a:r>
+          </a:p>
+          <a:p>
+            <a:pPr algn="ctr"/>
+            <a:endParaRPr lang="en-HU" sz="1200" b="1" dirty="0"/>
+          </a:p>
+          <a:p>
+            <a:pPr algn="ctr"/>
+            <a:r>
+              <a:rPr lang="en-GB" sz="1600" b="1" dirty="0"/>
+              <a:t>O</a:t>
+            </a:r>
+            <a:r>
+              <a:rPr lang="en-HU" sz="1600" b="1" dirty="0"/>
+              <a:t>bject rectangles and labels</a:t>
+            </a:r>
+          </a:p>
+          <a:p>
+            <a:pPr algn="ctr"/>
+            <a:endParaRPr lang="en-HU" sz="1600" b="1" dirty="0"/>
+          </a:p>
+          <a:p>
+            <a:pPr algn="ctr"/>
+            <a:r>
+              <a:rPr lang="en-HU" sz="1600" b="1" dirty="0"/>
+              <a:t>Human face rectangles</a:t>
+            </a:r>
+          </a:p>
+          <a:p>
+            <a:pPr algn="ctr"/>
+            <a:endParaRPr lang="en-HU" sz="1600" b="1" dirty="0"/>
+          </a:p>
+          <a:p>
+            <a:pPr algn="ctr"/>
+            <a:r>
+              <a:rPr lang="en-HU" sz="1600" b="1" dirty="0"/>
+              <a:t>EntityId</a:t>
+            </a:r>
+          </a:p>
+          <a:p>
+            <a:pPr algn="ctr"/>
+            <a:endParaRPr lang="en-HU" sz="1600" b="1" dirty="0"/>
+          </a:p>
+          <a:p>
+            <a:pPr algn="ctr"/>
+            <a:r>
+              <a:rPr lang="en-HU" sz="1600" b="1" dirty="0"/>
+              <a:t>PersonId</a:t>
+            </a:r>
+            <a:endParaRPr lang="en-HU" sz="1200" b="1" dirty="0"/>
+          </a:p>
+        </p:txBody>
+      </p:sp>
+      <p:cxnSp>
+        <p:nvCxnSpPr>
+          <p:cNvPr id="17" name="Straight Arrow Connector 16">
+            <a:extLst>
+              <a:ext uri="{FF2B5EF4-FFF2-40B4-BE49-F238E27FC236}">
+                <a16:creationId xmlns:a16="http://schemas.microsoft.com/office/drawing/2014/main" id="{47EDA51A-1D67-E95C-9111-615E80AAF5C1}"/>
+              </a:ext>
+            </a:extLst>
+          </p:cNvPr>
+          <p:cNvCxnSpPr>
+            <a:stCxn id="6" idx="2"/>
+            <a:endCxn id="7" idx="0"/>
+          </p:cNvCxnSpPr>
+          <p:nvPr/>
+        </p:nvCxnSpPr>
+        <p:spPr>
+          <a:xfrm flipH="1">
+            <a:off x="2999782" y="1748815"/>
+            <a:ext cx="6458" cy="793548"/>
+          </a:xfrm>
+          <a:prstGeom prst="straightConnector1">
+            <a:avLst/>
+          </a:prstGeom>
+          <a:ln>
+            <a:headEnd type="triangle"/>
+            <a:tailEnd type="triangle"/>
+          </a:ln>
+        </p:spPr>
+        <p:style>
+          <a:lnRef idx="3">
+            <a:schemeClr val="dk1"/>
+          </a:lnRef>
+          <a:fillRef idx="0">
+            <a:schemeClr val="dk1"/>
+          </a:fillRef>
+          <a:effectRef idx="2">
+            <a:schemeClr val="dk1"/>
+          </a:effectRef>
+          <a:fontRef idx="minor">
+            <a:schemeClr val="tx1"/>
+          </a:fontRef>
+        </p:style>
+      </p:cxnSp>
+      <p:cxnSp>
+        <p:nvCxnSpPr>
+          <p:cNvPr id="18" name="Straight Arrow Connector 17">
+            <a:extLst>
+              <a:ext uri="{FF2B5EF4-FFF2-40B4-BE49-F238E27FC236}">
+                <a16:creationId xmlns:a16="http://schemas.microsoft.com/office/drawing/2014/main" id="{2446C612-7808-7CB7-49C4-29D60F7B1A64}"/>
+              </a:ext>
+            </a:extLst>
+          </p:cNvPr>
+          <p:cNvCxnSpPr>
+            <a:cxnSpLocks/>
+            <a:stCxn id="8" idx="2"/>
+            <a:endCxn id="10" idx="0"/>
+          </p:cNvCxnSpPr>
+          <p:nvPr/>
+        </p:nvCxnSpPr>
+        <p:spPr>
+          <a:xfrm flipH="1">
+            <a:off x="4976916" y="1748815"/>
+            <a:ext cx="6458" cy="793545"/>
+          </a:xfrm>
+          <a:prstGeom prst="straightConnector1">
+            <a:avLst/>
+          </a:prstGeom>
+          <a:ln>
+            <a:headEnd type="triangle"/>
+            <a:tailEnd type="triangle"/>
+          </a:ln>
+        </p:spPr>
+        <p:style>
+          <a:lnRef idx="3">
+            <a:schemeClr val="dk1"/>
+          </a:lnRef>
+          <a:fillRef idx="0">
+            <a:schemeClr val="dk1"/>
+          </a:fillRef>
+          <a:effectRef idx="2">
+            <a:schemeClr val="dk1"/>
+          </a:effectRef>
+          <a:fontRef idx="minor">
+            <a:schemeClr val="tx1"/>
+          </a:fontRef>
+        </p:style>
+      </p:cxnSp>
+      <p:cxnSp>
+        <p:nvCxnSpPr>
+          <p:cNvPr id="19" name="Straight Arrow Connector 18">
+            <a:extLst>
+              <a:ext uri="{FF2B5EF4-FFF2-40B4-BE49-F238E27FC236}">
+                <a16:creationId xmlns:a16="http://schemas.microsoft.com/office/drawing/2014/main" id="{EB09D0A1-3EB0-6AE8-0994-93367BB53D49}"/>
+              </a:ext>
+            </a:extLst>
+          </p:cNvPr>
+          <p:cNvCxnSpPr>
+            <a:cxnSpLocks/>
+            <a:stCxn id="14" idx="2"/>
+            <a:endCxn id="13" idx="0"/>
+          </p:cNvCxnSpPr>
+          <p:nvPr/>
+        </p:nvCxnSpPr>
+        <p:spPr>
+          <a:xfrm flipH="1">
+            <a:off x="6954050" y="1748815"/>
+            <a:ext cx="6458" cy="793545"/>
+          </a:xfrm>
+          <a:prstGeom prst="straightConnector1">
+            <a:avLst/>
+          </a:prstGeom>
+          <a:ln>
+            <a:headEnd type="triangle"/>
+            <a:tailEnd type="triangle"/>
+          </a:ln>
+        </p:spPr>
+        <p:style>
+          <a:lnRef idx="3">
+            <a:schemeClr val="dk1"/>
+          </a:lnRef>
+          <a:fillRef idx="0">
+            <a:schemeClr val="dk1"/>
+          </a:fillRef>
+          <a:effectRef idx="2">
+            <a:schemeClr val="dk1"/>
+          </a:effectRef>
+          <a:fontRef idx="minor">
+            <a:schemeClr val="tx1"/>
+          </a:fontRef>
+        </p:style>
+      </p:cxnSp>
+      <p:cxnSp>
+        <p:nvCxnSpPr>
+          <p:cNvPr id="20" name="Straight Arrow Connector 19">
+            <a:extLst>
+              <a:ext uri="{FF2B5EF4-FFF2-40B4-BE49-F238E27FC236}">
+                <a16:creationId xmlns:a16="http://schemas.microsoft.com/office/drawing/2014/main" id="{C3AF397F-7DC8-B0F9-E727-7B0642523037}"/>
+              </a:ext>
+            </a:extLst>
+          </p:cNvPr>
+          <p:cNvCxnSpPr>
+            <a:cxnSpLocks/>
+            <a:stCxn id="11" idx="2"/>
+            <a:endCxn id="16" idx="0"/>
+          </p:cNvCxnSpPr>
+          <p:nvPr/>
+        </p:nvCxnSpPr>
+        <p:spPr>
+          <a:xfrm flipH="1">
+            <a:off x="8931184" y="1736851"/>
+            <a:ext cx="6458" cy="729288"/>
+          </a:xfrm>
+          <a:prstGeom prst="straightConnector1">
+            <a:avLst/>
+          </a:prstGeom>
+          <a:ln>
+            <a:headEnd type="triangle"/>
+            <a:tailEnd type="triangle"/>
+          </a:ln>
+        </p:spPr>
+        <p:style>
+          <a:lnRef idx="3">
+            <a:schemeClr val="dk1"/>
+          </a:lnRef>
+          <a:fillRef idx="0">
+            <a:schemeClr val="dk1"/>
+          </a:fillRef>
+          <a:effectRef idx="2">
+            <a:schemeClr val="dk1"/>
+          </a:effectRef>
+          <a:fontRef idx="minor">
+            <a:schemeClr val="tx1"/>
+          </a:fontRef>
+        </p:style>
+      </p:cxnSp>
+      <p:sp>
+        <p:nvSpPr>
+          <p:cNvPr id="21" name="Rounded Rectangle 20">
+            <a:extLst>
+              <a:ext uri="{FF2B5EF4-FFF2-40B4-BE49-F238E27FC236}">
+                <a16:creationId xmlns:a16="http://schemas.microsoft.com/office/drawing/2014/main" id="{4B86ADE1-4D23-3A51-6CBD-AE616CDE1557}"/>
+              </a:ext>
+            </a:extLst>
+          </p:cNvPr>
+          <p:cNvSpPr/>
+          <p:nvPr/>
+        </p:nvSpPr>
+        <p:spPr>
+          <a:xfrm>
+            <a:off x="10042566" y="782893"/>
+            <a:ext cx="1713611" cy="965922"/>
+          </a:xfrm>
+          <a:prstGeom prst="roundRect">
+            <a:avLst/>
+          </a:prstGeom>
+        </p:spPr>
+        <p:style>
+          <a:lnRef idx="2">
+            <a:schemeClr val="accent1">
+              <a:shade val="15000"/>
+            </a:schemeClr>
+          </a:lnRef>
+          <a:fillRef idx="1">
+            <a:schemeClr val="accent1"/>
+          </a:fillRef>
+          <a:effectRef idx="0">
+            <a:schemeClr val="accent1"/>
+          </a:effectRef>
+          <a:fontRef idx="minor">
+            <a:schemeClr val="lt1"/>
+          </a:fontRef>
+        </p:style>
+        <p:txBody>
+          <a:bodyPr rtlCol="0" anchor="ctr"/>
+          <a:lstStyle/>
+          <a:p>
+            <a:pPr algn="ctr"/>
+            <a:r>
+              <a:rPr lang="en-US" b="1" dirty="0"/>
+              <a:t>Messaging </a:t>
+            </a:r>
+            <a:r>
+              <a:rPr lang="en-US" sz="1400" b="1" dirty="0"/>
+              <a:t>triggers backend events: open door, etc.</a:t>
+            </a:r>
+            <a:endParaRPr lang="en-HU" sz="1400" b="1" dirty="0"/>
+          </a:p>
+        </p:txBody>
+      </p:sp>
+      <p:cxnSp>
+        <p:nvCxnSpPr>
+          <p:cNvPr id="22" name="Straight Arrow Connector 21">
+            <a:extLst>
+              <a:ext uri="{FF2B5EF4-FFF2-40B4-BE49-F238E27FC236}">
+                <a16:creationId xmlns:a16="http://schemas.microsoft.com/office/drawing/2014/main" id="{D9BC4AC3-1DC1-26F7-5696-21E7EF71581C}"/>
+              </a:ext>
+            </a:extLst>
+          </p:cNvPr>
+          <p:cNvCxnSpPr>
+            <a:cxnSpLocks/>
+            <a:stCxn id="11" idx="3"/>
+            <a:endCxn id="21" idx="1"/>
+          </p:cNvCxnSpPr>
+          <p:nvPr/>
+        </p:nvCxnSpPr>
+        <p:spPr>
+          <a:xfrm>
+            <a:off x="9794447" y="1253890"/>
+            <a:ext cx="248119" cy="11964"/>
+          </a:xfrm>
+          <a:prstGeom prst="straightConnector1">
+            <a:avLst/>
+          </a:prstGeom>
+          <a:ln>
+            <a:tailEnd type="triangle"/>
+          </a:ln>
+        </p:spPr>
+        <p:style>
+          <a:lnRef idx="3">
+            <a:schemeClr val="dk1"/>
+          </a:lnRef>
+          <a:fillRef idx="0">
+            <a:schemeClr val="dk1"/>
+          </a:fillRef>
+          <a:effectRef idx="2">
+            <a:schemeClr val="dk1"/>
+          </a:effectRef>
+          <a:fontRef idx="minor">
+            <a:schemeClr val="tx1"/>
+          </a:fontRef>
+        </p:style>
+      </p:cxnSp>
+      <p:sp>
+        <p:nvSpPr>
+          <p:cNvPr id="23" name="Rounded Rectangle 22">
+            <a:extLst>
+              <a:ext uri="{FF2B5EF4-FFF2-40B4-BE49-F238E27FC236}">
+                <a16:creationId xmlns:a16="http://schemas.microsoft.com/office/drawing/2014/main" id="{5F4047FF-6BBD-A0D1-9D49-9A0FDB514F27}"/>
+              </a:ext>
+            </a:extLst>
+          </p:cNvPr>
+          <p:cNvSpPr/>
+          <p:nvPr/>
+        </p:nvSpPr>
+        <p:spPr>
+          <a:xfrm>
+            <a:off x="10150580" y="2466139"/>
+            <a:ext cx="1713611" cy="3495358"/>
+          </a:xfrm>
+          <a:prstGeom prst="roundRect">
+            <a:avLst/>
+          </a:prstGeom>
+          <a:solidFill>
+            <a:schemeClr val="accent4">
+              <a:lumMod val="60000"/>
+              <a:lumOff val="40000"/>
+            </a:schemeClr>
+          </a:solidFill>
+        </p:spPr>
+        <p:style>
+          <a:lnRef idx="2">
+            <a:schemeClr val="accent1">
+              <a:shade val="15000"/>
+            </a:schemeClr>
+          </a:lnRef>
+          <a:fillRef idx="1">
+            <a:schemeClr val="accent1"/>
+          </a:fillRef>
+          <a:effectRef idx="0">
+            <a:schemeClr val="accent1"/>
+          </a:effectRef>
+          <a:fontRef idx="minor">
+            <a:schemeClr val="lt1"/>
+          </a:fontRef>
+        </p:style>
+        <p:txBody>
+          <a:bodyPr rtlCol="0" anchor="ctr"/>
+          <a:lstStyle/>
+          <a:p>
+            <a:pPr algn="ctr"/>
+            <a:r>
+              <a:rPr lang="en-HU" sz="1200" b="1" dirty="0"/>
+              <a:t>Perception</a:t>
+            </a:r>
+          </a:p>
+          <a:p>
+            <a:pPr algn="ctr"/>
+            <a:r>
+              <a:rPr lang="en-HU" sz="1200" b="1" dirty="0"/>
+              <a:t>Context attachments:</a:t>
+            </a:r>
+          </a:p>
+          <a:p>
+            <a:pPr algn="ctr"/>
+            <a:endParaRPr lang="en-HU" sz="1200" b="1" dirty="0"/>
+          </a:p>
+          <a:p>
+            <a:pPr algn="ctr"/>
+            <a:r>
+              <a:rPr lang="en-GB" sz="1600" b="1" dirty="0"/>
+              <a:t>O</a:t>
+            </a:r>
+            <a:r>
+              <a:rPr lang="en-HU" sz="1600" b="1" dirty="0"/>
+              <a:t>bject rectangles and labels</a:t>
+            </a:r>
+          </a:p>
+          <a:p>
+            <a:pPr algn="ctr"/>
+            <a:endParaRPr lang="en-HU" sz="1600" b="1" dirty="0"/>
+          </a:p>
+          <a:p>
+            <a:pPr algn="ctr"/>
+            <a:r>
+              <a:rPr lang="en-HU" sz="1600" b="1" dirty="0"/>
+              <a:t>Human face rectangles</a:t>
+            </a:r>
+          </a:p>
+          <a:p>
+            <a:pPr algn="ctr"/>
+            <a:endParaRPr lang="en-HU" sz="1600" b="1" dirty="0"/>
+          </a:p>
+          <a:p>
+            <a:pPr algn="ctr"/>
+            <a:r>
+              <a:rPr lang="en-HU" sz="1600" b="1" dirty="0"/>
+              <a:t>EntityId</a:t>
+            </a:r>
+          </a:p>
+          <a:p>
+            <a:pPr algn="ctr"/>
+            <a:endParaRPr lang="en-HU" sz="1600" b="1" dirty="0"/>
+          </a:p>
+          <a:p>
+            <a:pPr algn="ctr"/>
+            <a:r>
+              <a:rPr lang="en-HU" sz="1600" b="1" dirty="0"/>
+              <a:t>PersonId</a:t>
+            </a:r>
+            <a:endParaRPr lang="en-HU" sz="1200" b="1" dirty="0"/>
+          </a:p>
+        </p:txBody>
+      </p:sp>
+      <p:cxnSp>
+        <p:nvCxnSpPr>
+          <p:cNvPr id="24" name="Straight Arrow Connector 23">
+            <a:extLst>
+              <a:ext uri="{FF2B5EF4-FFF2-40B4-BE49-F238E27FC236}">
+                <a16:creationId xmlns:a16="http://schemas.microsoft.com/office/drawing/2014/main" id="{7D8FA37E-002B-8FF5-9882-27A420DE5C68}"/>
+              </a:ext>
+            </a:extLst>
+          </p:cNvPr>
+          <p:cNvCxnSpPr>
+            <a:cxnSpLocks/>
+            <a:endCxn id="23" idx="0"/>
+          </p:cNvCxnSpPr>
+          <p:nvPr/>
+        </p:nvCxnSpPr>
+        <p:spPr>
+          <a:xfrm>
+            <a:off x="11007386" y="1748815"/>
+            <a:ext cx="0" cy="717324"/>
+          </a:xfrm>
+          <a:prstGeom prst="straightConnector1">
+            <a:avLst/>
+          </a:prstGeom>
+          <a:ln>
+            <a:headEnd type="triangle"/>
+            <a:tailEnd type="triangle"/>
+          </a:ln>
+        </p:spPr>
+        <p:style>
+          <a:lnRef idx="3">
+            <a:schemeClr val="dk1"/>
+          </a:lnRef>
+          <a:fillRef idx="0">
+            <a:schemeClr val="dk1"/>
+          </a:fillRef>
+          <a:effectRef idx="2">
+            <a:schemeClr val="dk1"/>
+          </a:effectRef>
+          <a:fontRef idx="minor">
+            <a:schemeClr val="tx1"/>
+          </a:fontRef>
+        </p:style>
+      </p:cxnSp>
+      <p:cxnSp>
+        <p:nvCxnSpPr>
+          <p:cNvPr id="25" name="Straight Arrow Connector 24">
+            <a:extLst>
+              <a:ext uri="{FF2B5EF4-FFF2-40B4-BE49-F238E27FC236}">
+                <a16:creationId xmlns:a16="http://schemas.microsoft.com/office/drawing/2014/main" id="{257266AA-E294-459D-387B-9CA54DCB7CE7}"/>
+              </a:ext>
+            </a:extLst>
+          </p:cNvPr>
+          <p:cNvCxnSpPr>
+            <a:cxnSpLocks/>
+          </p:cNvCxnSpPr>
+          <p:nvPr/>
+        </p:nvCxnSpPr>
+        <p:spPr>
+          <a:xfrm>
+            <a:off x="11756177" y="1282821"/>
+            <a:ext cx="263523" cy="0"/>
+          </a:xfrm>
+          <a:prstGeom prst="straightConnector1">
+            <a:avLst/>
+          </a:prstGeom>
+          <a:ln>
+            <a:tailEnd type="triangle"/>
+          </a:ln>
+        </p:spPr>
+        <p:style>
+          <a:lnRef idx="3">
+            <a:schemeClr val="dk1"/>
+          </a:lnRef>
+          <a:fillRef idx="0">
+            <a:schemeClr val="dk1"/>
+          </a:fillRef>
+          <a:effectRef idx="2">
+            <a:schemeClr val="dk1"/>
+          </a:effectRef>
+          <a:fontRef idx="minor">
+            <a:schemeClr val="tx1"/>
+          </a:fontRef>
+        </p:style>
+      </p:cxnSp>
+      <p:sp>
+        <p:nvSpPr>
+          <p:cNvPr id="27" name="TextBox 26">
+            <a:extLst>
+              <a:ext uri="{FF2B5EF4-FFF2-40B4-BE49-F238E27FC236}">
+                <a16:creationId xmlns:a16="http://schemas.microsoft.com/office/drawing/2014/main" id="{678DC7D0-A96C-4762-E2B4-616375A183C3}"/>
+              </a:ext>
+            </a:extLst>
+          </p:cNvPr>
+          <p:cNvSpPr txBox="1"/>
+          <p:nvPr/>
+        </p:nvSpPr>
+        <p:spPr>
+          <a:xfrm>
+            <a:off x="0" y="27864"/>
+            <a:ext cx="12046360" cy="646331"/>
+          </a:xfrm>
+          <a:prstGeom prst="rect">
+            <a:avLst/>
+          </a:prstGeom>
+          <a:noFill/>
+        </p:spPr>
+        <p:txBody>
+          <a:bodyPr wrap="square" rtlCol="0">
+            <a:spAutoFit/>
+          </a:bodyPr>
+          <a:lstStyle/>
+          <a:p>
+            <a:pPr algn="ctr"/>
+            <a:r>
+              <a:rPr lang="en-HU" sz="3600" b="1" dirty="0">
+                <a:latin typeface="Consolas" panose="020B0609020204030204" pitchFamily="49" charset="0"/>
+                <a:cs typeface="Consolas" panose="020B0609020204030204" pitchFamily="49" charset="0"/>
+              </a:rPr>
+              <a:t>Inference Data Collection (Perception)</a:t>
+            </a:r>
+          </a:p>
+        </p:txBody>
+      </p:sp>
+    </p:spTree>
+    <p:extLst>
+      <p:ext uri="{BB962C8B-B14F-4D97-AF65-F5344CB8AC3E}">
+        <p14:creationId xmlns:p14="http://schemas.microsoft.com/office/powerpoint/2010/main" val="2526206157"/>
+      </p:ext>
+    </p:extLst>
+  </p:cSld>
+  <p:clrMapOvr>
+    <a:masterClrMapping/>
+  </p:clrMapOvr>
+</p:sld>
+</file>
+
+<file path=ppt/slides/slide3.xml><?xml version="1.0" encoding="utf-8"?>
+<p:sld xmlns:a="http://schemas.openxmlformats.org/drawingml/2006/main" xmlns:r="http://schemas.openxmlformats.org/officeDocument/2006/relationships" xmlns:p="http://schemas.openxmlformats.org/presentationml/2006/main">
+  <p:cSld>
+    <p:spTree>
+      <p:nvGrpSpPr>
+        <p:cNvPr id="1" name=""/>
+        <p:cNvGrpSpPr/>
+        <p:nvPr/>
+      </p:nvGrpSpPr>
+      <p:grpSpPr>
+        <a:xfrm>
+          <a:off x="0" y="0"/>
+          <a:ext cx="0" cy="0"/>
+          <a:chOff x="0" y="0"/>
+          <a:chExt cx="0" cy="0"/>
+        </a:xfrm>
+      </p:grpSpPr>
+      <p:sp>
+        <p:nvSpPr>
+          <p:cNvPr id="4" name="Rectangle 3">
+            <a:extLst>
+              <a:ext uri="{FF2B5EF4-FFF2-40B4-BE49-F238E27FC236}">
+                <a16:creationId xmlns:a16="http://schemas.microsoft.com/office/drawing/2014/main" id="{A9AC2D0D-B2AD-DBEC-579B-BBD12CEC66B0}"/>
+              </a:ext>
+            </a:extLst>
+          </p:cNvPr>
+          <p:cNvSpPr/>
+          <p:nvPr/>
+        </p:nvSpPr>
+        <p:spPr>
+          <a:xfrm>
+            <a:off x="1779055" y="2354306"/>
+            <a:ext cx="2749136" cy="1913022"/>
+          </a:xfrm>
+          <a:prstGeom prst="rect">
+            <a:avLst/>
+          </a:prstGeom>
+        </p:spPr>
+        <p:style>
+          <a:lnRef idx="2">
+            <a:schemeClr val="accent1">
+              <a:shade val="15000"/>
+            </a:schemeClr>
+          </a:lnRef>
+          <a:fillRef idx="1">
+            <a:schemeClr val="accent1"/>
+          </a:fillRef>
+          <a:effectRef idx="0">
+            <a:schemeClr val="accent1"/>
+          </a:effectRef>
+          <a:fontRef idx="minor">
+            <a:schemeClr val="lt1"/>
+          </a:fontRef>
+        </p:style>
+        <p:txBody>
+          <a:bodyPr rtlCol="0" anchor="ctr"/>
+          <a:lstStyle/>
+          <a:p>
+            <a:pPr algn="ctr"/>
+            <a:r>
+              <a:rPr lang="en-HU" sz="2000" b="1" dirty="0"/>
+              <a:t>Container</a:t>
+            </a:r>
+            <a:endParaRPr lang="en-HU" b="1" dirty="0"/>
+          </a:p>
+          <a:p>
+            <a:pPr algn="ctr"/>
+            <a:r>
+              <a:rPr lang="en-HU" dirty="0"/>
+              <a:t>executes pipeline</a:t>
+            </a:r>
+          </a:p>
+        </p:txBody>
+      </p:sp>
+      <p:sp>
+        <p:nvSpPr>
+          <p:cNvPr id="5" name="Rectangle 4">
+            <a:extLst>
+              <a:ext uri="{FF2B5EF4-FFF2-40B4-BE49-F238E27FC236}">
+                <a16:creationId xmlns:a16="http://schemas.microsoft.com/office/drawing/2014/main" id="{D652482A-FD0E-69C2-C1B0-A1A1FE4FDD4B}"/>
+              </a:ext>
+            </a:extLst>
+          </p:cNvPr>
+          <p:cNvSpPr/>
+          <p:nvPr/>
+        </p:nvSpPr>
+        <p:spPr>
+          <a:xfrm>
+            <a:off x="7885533" y="2354306"/>
+            <a:ext cx="2749136" cy="1913022"/>
+          </a:xfrm>
+          <a:prstGeom prst="rect">
+            <a:avLst/>
+          </a:prstGeom>
+        </p:spPr>
+        <p:style>
+          <a:lnRef idx="2">
+            <a:schemeClr val="accent1">
+              <a:shade val="15000"/>
+            </a:schemeClr>
+          </a:lnRef>
+          <a:fillRef idx="1">
+            <a:schemeClr val="accent1"/>
+          </a:fillRef>
+          <a:effectRef idx="0">
+            <a:schemeClr val="accent1"/>
+          </a:effectRef>
+          <a:fontRef idx="minor">
+            <a:schemeClr val="lt1"/>
+          </a:fontRef>
+        </p:style>
+        <p:txBody>
+          <a:bodyPr rtlCol="0" anchor="ctr"/>
+          <a:lstStyle/>
+          <a:p>
+            <a:pPr algn="ctr"/>
+            <a:r>
+              <a:rPr lang="en-HU" sz="2000" b="1" dirty="0"/>
+              <a:t>Host Web Browser</a:t>
+            </a:r>
+            <a:endParaRPr lang="en-HU" b="1" dirty="0"/>
+          </a:p>
+          <a:p>
+            <a:pPr algn="ctr"/>
+            <a:r>
+              <a:rPr lang="en-GB" dirty="0"/>
+              <a:t>presents</a:t>
+            </a:r>
+            <a:r>
+              <a:rPr lang="en-HU" dirty="0"/>
+              <a:t> media and handles input</a:t>
+            </a:r>
+          </a:p>
+        </p:txBody>
+      </p:sp>
+      <p:cxnSp>
+        <p:nvCxnSpPr>
+          <p:cNvPr id="6" name="Straight Arrow Connector 5">
+            <a:extLst>
+              <a:ext uri="{FF2B5EF4-FFF2-40B4-BE49-F238E27FC236}">
+                <a16:creationId xmlns:a16="http://schemas.microsoft.com/office/drawing/2014/main" id="{036D1C21-39DE-1679-59B4-B2478EF40419}"/>
+              </a:ext>
+            </a:extLst>
+          </p:cNvPr>
+          <p:cNvCxnSpPr/>
+          <p:nvPr/>
+        </p:nvCxnSpPr>
+        <p:spPr>
+          <a:xfrm>
+            <a:off x="4528191" y="4087740"/>
+            <a:ext cx="3357342" cy="0"/>
+          </a:xfrm>
+          <a:prstGeom prst="straightConnector1">
+            <a:avLst/>
+          </a:prstGeom>
+          <a:ln>
+            <a:tailEnd type="triangle"/>
+          </a:ln>
+        </p:spPr>
+        <p:style>
+          <a:lnRef idx="3">
+            <a:schemeClr val="dk1"/>
+          </a:lnRef>
+          <a:fillRef idx="0">
+            <a:schemeClr val="dk1"/>
+          </a:fillRef>
+          <a:effectRef idx="2">
+            <a:schemeClr val="dk1"/>
+          </a:effectRef>
+          <a:fontRef idx="minor">
+            <a:schemeClr val="tx1"/>
+          </a:fontRef>
+        </p:style>
+      </p:cxnSp>
+      <p:cxnSp>
+        <p:nvCxnSpPr>
+          <p:cNvPr id="7" name="Straight Arrow Connector 6">
+            <a:extLst>
+              <a:ext uri="{FF2B5EF4-FFF2-40B4-BE49-F238E27FC236}">
+                <a16:creationId xmlns:a16="http://schemas.microsoft.com/office/drawing/2014/main" id="{FA7FA657-B2C2-60CB-D138-FDD8E5558619}"/>
+              </a:ext>
+            </a:extLst>
+          </p:cNvPr>
+          <p:cNvCxnSpPr>
+            <a:cxnSpLocks/>
+          </p:cNvCxnSpPr>
+          <p:nvPr/>
+        </p:nvCxnSpPr>
+        <p:spPr>
+          <a:xfrm flipH="1">
+            <a:off x="4528191" y="3780701"/>
+            <a:ext cx="3357342" cy="0"/>
+          </a:xfrm>
+          <a:prstGeom prst="straightConnector1">
+            <a:avLst/>
+          </a:prstGeom>
+          <a:ln>
+            <a:tailEnd type="triangle"/>
+          </a:ln>
+        </p:spPr>
+        <p:style>
+          <a:lnRef idx="3">
+            <a:schemeClr val="dk1"/>
+          </a:lnRef>
+          <a:fillRef idx="0">
+            <a:schemeClr val="dk1"/>
+          </a:fillRef>
+          <a:effectRef idx="2">
+            <a:schemeClr val="dk1"/>
+          </a:effectRef>
+          <a:fontRef idx="minor">
+            <a:schemeClr val="tx1"/>
+          </a:fontRef>
+        </p:style>
+      </p:cxnSp>
+      <p:cxnSp>
+        <p:nvCxnSpPr>
+          <p:cNvPr id="8" name="Straight Arrow Connector 7">
+            <a:extLst>
+              <a:ext uri="{FF2B5EF4-FFF2-40B4-BE49-F238E27FC236}">
+                <a16:creationId xmlns:a16="http://schemas.microsoft.com/office/drawing/2014/main" id="{D2CF9E3D-9F9F-B8A6-B3FC-EA4949358F82}"/>
+              </a:ext>
+            </a:extLst>
+          </p:cNvPr>
+          <p:cNvCxnSpPr>
+            <a:cxnSpLocks/>
+          </p:cNvCxnSpPr>
+          <p:nvPr/>
+        </p:nvCxnSpPr>
+        <p:spPr>
+          <a:xfrm flipH="1">
+            <a:off x="4528191" y="2648988"/>
+            <a:ext cx="3357342" cy="0"/>
+          </a:xfrm>
+          <a:prstGeom prst="straightConnector1">
+            <a:avLst/>
+          </a:prstGeom>
+          <a:ln>
+            <a:tailEnd type="triangle"/>
+          </a:ln>
+        </p:spPr>
+        <p:style>
+          <a:lnRef idx="3">
+            <a:schemeClr val="dk1"/>
+          </a:lnRef>
+          <a:fillRef idx="0">
+            <a:schemeClr val="dk1"/>
+          </a:fillRef>
+          <a:effectRef idx="2">
+            <a:schemeClr val="dk1"/>
+          </a:effectRef>
+          <a:fontRef idx="minor">
+            <a:schemeClr val="tx1"/>
+          </a:fontRef>
+        </p:style>
+      </p:cxnSp>
+      <p:sp>
+        <p:nvSpPr>
+          <p:cNvPr id="9" name="TextBox 8">
+            <a:extLst>
+              <a:ext uri="{FF2B5EF4-FFF2-40B4-BE49-F238E27FC236}">
+                <a16:creationId xmlns:a16="http://schemas.microsoft.com/office/drawing/2014/main" id="{61B184AB-0E13-B984-930F-6B670E0F1C83}"/>
+              </a:ext>
+            </a:extLst>
+          </p:cNvPr>
+          <p:cNvSpPr txBox="1"/>
+          <p:nvPr/>
+        </p:nvSpPr>
+        <p:spPr>
+          <a:xfrm>
+            <a:off x="4893618" y="3411369"/>
+            <a:ext cx="2626488" cy="369332"/>
+          </a:xfrm>
+          <a:prstGeom prst="rect">
+            <a:avLst/>
+          </a:prstGeom>
+          <a:noFill/>
+        </p:spPr>
+        <p:txBody>
+          <a:bodyPr wrap="none" rtlCol="0">
+            <a:spAutoFit/>
+          </a:bodyPr>
+          <a:lstStyle/>
+          <a:p>
+            <a:r>
+              <a:rPr lang="en-HU" dirty="0"/>
+              <a:t>REST control commands</a:t>
+            </a:r>
+          </a:p>
+        </p:txBody>
+      </p:sp>
+      <p:sp>
+        <p:nvSpPr>
+          <p:cNvPr id="10" name="TextBox 9">
+            <a:extLst>
+              <a:ext uri="{FF2B5EF4-FFF2-40B4-BE49-F238E27FC236}">
+                <a16:creationId xmlns:a16="http://schemas.microsoft.com/office/drawing/2014/main" id="{E5F16968-75AA-1DCE-5E80-A4B5190213D4}"/>
+              </a:ext>
+            </a:extLst>
+          </p:cNvPr>
+          <p:cNvSpPr txBox="1"/>
+          <p:nvPr/>
+        </p:nvSpPr>
+        <p:spPr>
+          <a:xfrm>
+            <a:off x="5261337" y="2252847"/>
+            <a:ext cx="1514454" cy="369332"/>
+          </a:xfrm>
+          <a:prstGeom prst="rect">
+            <a:avLst/>
+          </a:prstGeom>
+          <a:noFill/>
+        </p:spPr>
+        <p:txBody>
+          <a:bodyPr wrap="none" rtlCol="0">
+            <a:spAutoFit/>
+          </a:bodyPr>
+          <a:lstStyle/>
+          <a:p>
+            <a:r>
+              <a:rPr lang="en-HU" dirty="0"/>
+              <a:t>Webcam/Mic</a:t>
+            </a:r>
+          </a:p>
+        </p:txBody>
+      </p:sp>
+      <p:sp>
+        <p:nvSpPr>
+          <p:cNvPr id="11" name="Rounded Rectangle 10">
+            <a:extLst>
+              <a:ext uri="{FF2B5EF4-FFF2-40B4-BE49-F238E27FC236}">
+                <a16:creationId xmlns:a16="http://schemas.microsoft.com/office/drawing/2014/main" id="{F96C9BA2-6C37-75E2-C03A-6E6D0796AB03}"/>
+              </a:ext>
+            </a:extLst>
+          </p:cNvPr>
+          <p:cNvSpPr/>
+          <p:nvPr/>
+        </p:nvSpPr>
+        <p:spPr>
+          <a:xfrm>
+            <a:off x="3153623" y="3663743"/>
+            <a:ext cx="1307787" cy="522903"/>
+          </a:xfrm>
+          <a:prstGeom prst="roundRect">
+            <a:avLst/>
+          </a:prstGeom>
+          <a:solidFill>
+            <a:schemeClr val="accent6">
+              <a:lumMod val="75000"/>
+            </a:schemeClr>
+          </a:solidFill>
+        </p:spPr>
+        <p:style>
+          <a:lnRef idx="2">
+            <a:schemeClr val="accent1">
+              <a:shade val="15000"/>
+            </a:schemeClr>
+          </a:lnRef>
+          <a:fillRef idx="1">
+            <a:schemeClr val="accent1"/>
+          </a:fillRef>
+          <a:effectRef idx="0">
+            <a:schemeClr val="accent1"/>
+          </a:effectRef>
+          <a:fontRef idx="minor">
+            <a:schemeClr val="lt1"/>
+          </a:fontRef>
+        </p:style>
+        <p:txBody>
+          <a:bodyPr rtlCol="0" anchor="ctr"/>
+          <a:lstStyle/>
+          <a:p>
+            <a:pPr algn="ctr"/>
+            <a:r>
+              <a:rPr lang="en-HU" sz="1400" b="1" dirty="0"/>
+              <a:t>AmpSink</a:t>
+            </a:r>
+          </a:p>
+        </p:txBody>
+      </p:sp>
+      <p:sp>
+        <p:nvSpPr>
+          <p:cNvPr id="12" name="Rounded Rectangle 11">
+            <a:extLst>
+              <a:ext uri="{FF2B5EF4-FFF2-40B4-BE49-F238E27FC236}">
+                <a16:creationId xmlns:a16="http://schemas.microsoft.com/office/drawing/2014/main" id="{C2F3DAE5-14C0-9609-FB55-11DCF815E69D}"/>
+              </a:ext>
+            </a:extLst>
+          </p:cNvPr>
+          <p:cNvSpPr/>
+          <p:nvPr/>
+        </p:nvSpPr>
+        <p:spPr>
+          <a:xfrm>
+            <a:off x="3153622" y="2416896"/>
+            <a:ext cx="1307787" cy="522903"/>
+          </a:xfrm>
+          <a:prstGeom prst="roundRect">
+            <a:avLst/>
+          </a:prstGeom>
+          <a:solidFill>
+            <a:schemeClr val="accent6">
+              <a:lumMod val="75000"/>
+            </a:schemeClr>
+          </a:solidFill>
+        </p:spPr>
+        <p:style>
+          <a:lnRef idx="2">
+            <a:schemeClr val="accent1">
+              <a:shade val="15000"/>
+            </a:schemeClr>
+          </a:lnRef>
+          <a:fillRef idx="1">
+            <a:schemeClr val="accent1"/>
+          </a:fillRef>
+          <a:effectRef idx="0">
+            <a:schemeClr val="accent1"/>
+          </a:effectRef>
+          <a:fontRef idx="minor">
+            <a:schemeClr val="lt1"/>
+          </a:fontRef>
+        </p:style>
+        <p:txBody>
+          <a:bodyPr rtlCol="0" anchor="ctr"/>
+          <a:lstStyle/>
+          <a:p>
+            <a:pPr algn="ctr"/>
+            <a:r>
+              <a:rPr lang="en-HU" sz="1400" b="1" dirty="0"/>
+              <a:t>AmpSource</a:t>
+            </a:r>
+          </a:p>
+        </p:txBody>
+      </p:sp>
+    </p:spTree>
+    <p:extLst>
+      <p:ext uri="{BB962C8B-B14F-4D97-AF65-F5344CB8AC3E}">
+        <p14:creationId xmlns:p14="http://schemas.microsoft.com/office/powerpoint/2010/main" val="930730432"/>
+      </p:ext>
+    </p:extLst>
+  </p:cSld>
+  <p:clrMapOvr>
+    <a:masterClrMapping/>
+  </p:clrMapOvr>
+</p:sld>
+</file>
+
+<file path=ppt/slides/slide4.xml><?xml version="1.0" encoding="utf-8"?>
+<p:sld xmlns:a="http://schemas.openxmlformats.org/drawingml/2006/main" xmlns:r="http://schemas.openxmlformats.org/officeDocument/2006/relationships" xmlns:p="http://schemas.openxmlformats.org/presentationml/2006/main">
+  <p:cSld>
+    <p:spTree>
+      <p:nvGrpSpPr>
+        <p:cNvPr id="1" name=""/>
+        <p:cNvGrpSpPr/>
+        <p:nvPr/>
+      </p:nvGrpSpPr>
+      <p:grpSpPr>
+        <a:xfrm>
+          <a:off x="0" y="0"/>
+          <a:ext cx="0" cy="0"/>
+          <a:chOff x="0" y="0"/>
+          <a:chExt cx="0" cy="0"/>
+        </a:xfrm>
+      </p:grpSpPr>
+      <p:sp>
+        <p:nvSpPr>
+          <p:cNvPr id="4" name="Rounded Rectangle 3">
+            <a:extLst>
+              <a:ext uri="{FF2B5EF4-FFF2-40B4-BE49-F238E27FC236}">
+                <a16:creationId xmlns:a16="http://schemas.microsoft.com/office/drawing/2014/main" id="{BE7F998C-E105-A5CE-F8C3-CE9298070640}"/>
+              </a:ext>
+            </a:extLst>
+          </p:cNvPr>
+          <p:cNvSpPr/>
+          <p:nvPr/>
+        </p:nvSpPr>
+        <p:spPr>
+          <a:xfrm>
+            <a:off x="6723704" y="2066307"/>
+            <a:ext cx="4040988" cy="1769422"/>
+          </a:xfrm>
+          <a:prstGeom prst="roundRect">
+            <a:avLst/>
+          </a:prstGeom>
+          <a:solidFill>
+            <a:schemeClr val="accent6">
+              <a:lumMod val="75000"/>
+            </a:schemeClr>
+          </a:solidFill>
+        </p:spPr>
+        <p:style>
+          <a:lnRef idx="2">
+            <a:schemeClr val="accent1">
+              <a:shade val="15000"/>
+            </a:schemeClr>
+          </a:lnRef>
+          <a:fillRef idx="1">
+            <a:schemeClr val="accent1"/>
+          </a:fillRef>
+          <a:effectRef idx="0">
+            <a:schemeClr val="accent1"/>
+          </a:effectRef>
+          <a:fontRef idx="minor">
+            <a:schemeClr val="lt1"/>
+          </a:fontRef>
+        </p:style>
+        <p:txBody>
+          <a:bodyPr rtlCol="0" anchor="ctr"/>
+          <a:lstStyle/>
+          <a:p>
+            <a:pPr algn="ctr"/>
+            <a:r>
+              <a:rPr lang="en-HU" b="1" dirty="0"/>
+              <a:t>AMP-Model</a:t>
+            </a:r>
+          </a:p>
+          <a:p>
+            <a:pPr algn="ctr"/>
+            <a:r>
+              <a:rPr lang="en-HU" sz="1400" dirty="0"/>
+              <a:t>API agnostic</a:t>
+            </a:r>
+          </a:p>
+          <a:p>
+            <a:pPr algn="ctr"/>
+            <a:r>
+              <a:rPr lang="en-HU" sz="1400" dirty="0"/>
+              <a:t>Generic model descriptor</a:t>
+            </a:r>
+          </a:p>
+          <a:p>
+            <a:pPr algn="ctr"/>
+            <a:r>
+              <a:rPr lang="en-HU" sz="1400" dirty="0"/>
+              <a:t>Input-output formats</a:t>
+            </a:r>
+          </a:p>
+          <a:p>
+            <a:pPr algn="ctr"/>
+            <a:r>
+              <a:rPr lang="en-HU" sz="1400" dirty="0"/>
+              <a:t>Input builder type</a:t>
+            </a:r>
+          </a:p>
+          <a:p>
+            <a:pPr algn="ctr"/>
+            <a:r>
+              <a:rPr lang="en-HU" sz="1400" dirty="0"/>
+              <a:t>Postprocessor type</a:t>
+            </a:r>
+          </a:p>
+          <a:p>
+            <a:pPr algn="ctr"/>
+            <a:r>
+              <a:rPr lang="en-HU" sz="1400" dirty="0"/>
+              <a:t>Inference config</a:t>
+            </a:r>
+            <a:endParaRPr lang="en-HU" dirty="0"/>
+          </a:p>
+        </p:txBody>
+      </p:sp>
+      <p:sp>
+        <p:nvSpPr>
+          <p:cNvPr id="5" name="Rounded Rectangle 4">
+            <a:extLst>
+              <a:ext uri="{FF2B5EF4-FFF2-40B4-BE49-F238E27FC236}">
+                <a16:creationId xmlns:a16="http://schemas.microsoft.com/office/drawing/2014/main" id="{129E9CD7-FC1F-16B0-6EB3-2277D8077D1E}"/>
+              </a:ext>
+            </a:extLst>
+          </p:cNvPr>
+          <p:cNvSpPr/>
+          <p:nvPr/>
+        </p:nvSpPr>
+        <p:spPr>
+          <a:xfrm>
+            <a:off x="5502749" y="134466"/>
+            <a:ext cx="1713611" cy="965922"/>
+          </a:xfrm>
+          <a:prstGeom prst="roundRect">
+            <a:avLst/>
+          </a:prstGeom>
+        </p:spPr>
+        <p:style>
+          <a:lnRef idx="2">
+            <a:schemeClr val="accent1">
+              <a:shade val="15000"/>
+            </a:schemeClr>
+          </a:lnRef>
+          <a:fillRef idx="1">
+            <a:schemeClr val="accent1"/>
+          </a:fillRef>
+          <a:effectRef idx="0">
+            <a:schemeClr val="accent1"/>
+          </a:effectRef>
+          <a:fontRef idx="minor">
+            <a:schemeClr val="lt1"/>
+          </a:fontRef>
+        </p:style>
+        <p:txBody>
+          <a:bodyPr rtlCol="0" anchor="ctr"/>
+          <a:lstStyle/>
+          <a:p>
+            <a:pPr algn="ctr"/>
+            <a:r>
+              <a:rPr lang="en-HU" b="1" dirty="0"/>
+              <a:t>ONNX Runtime .onnx file</a:t>
+            </a:r>
+          </a:p>
+        </p:txBody>
+      </p:sp>
+      <p:sp>
+        <p:nvSpPr>
+          <p:cNvPr id="6" name="Rounded Rectangle 5">
+            <a:extLst>
+              <a:ext uri="{FF2B5EF4-FFF2-40B4-BE49-F238E27FC236}">
+                <a16:creationId xmlns:a16="http://schemas.microsoft.com/office/drawing/2014/main" id="{15E6C299-ADF2-DE0A-2353-D7CA0F83281C}"/>
+              </a:ext>
+            </a:extLst>
+          </p:cNvPr>
+          <p:cNvSpPr/>
+          <p:nvPr/>
+        </p:nvSpPr>
+        <p:spPr>
+          <a:xfrm>
+            <a:off x="7754587" y="134462"/>
+            <a:ext cx="1935678" cy="965923"/>
+          </a:xfrm>
+          <a:prstGeom prst="roundRect">
+            <a:avLst/>
+          </a:prstGeom>
+        </p:spPr>
+        <p:style>
+          <a:lnRef idx="2">
+            <a:schemeClr val="accent1">
+              <a:shade val="15000"/>
+            </a:schemeClr>
+          </a:lnRef>
+          <a:fillRef idx="1">
+            <a:schemeClr val="accent1"/>
+          </a:fillRef>
+          <a:effectRef idx="0">
+            <a:schemeClr val="accent1"/>
+          </a:effectRef>
+          <a:fontRef idx="minor">
+            <a:schemeClr val="lt1"/>
+          </a:fontRef>
+        </p:style>
+        <p:txBody>
+          <a:bodyPr rtlCol="0" anchor="ctr"/>
+          <a:lstStyle/>
+          <a:p>
+            <a:pPr algn="ctr"/>
+            <a:r>
+              <a:rPr lang="en-HU" b="1" dirty="0"/>
+              <a:t>HailoRT .hef file</a:t>
+            </a:r>
+          </a:p>
+        </p:txBody>
+      </p:sp>
+      <p:sp>
+        <p:nvSpPr>
+          <p:cNvPr id="7" name="Rounded Rectangle 6">
+            <a:extLst>
+              <a:ext uri="{FF2B5EF4-FFF2-40B4-BE49-F238E27FC236}">
+                <a16:creationId xmlns:a16="http://schemas.microsoft.com/office/drawing/2014/main" id="{2DC4BD53-543A-1EDA-5379-D678674C35EB}"/>
+              </a:ext>
+            </a:extLst>
+          </p:cNvPr>
+          <p:cNvSpPr/>
+          <p:nvPr/>
+        </p:nvSpPr>
+        <p:spPr>
+          <a:xfrm>
+            <a:off x="10170991" y="134461"/>
+            <a:ext cx="1685130" cy="965923"/>
+          </a:xfrm>
+          <a:prstGeom prst="roundRect">
+            <a:avLst/>
+          </a:prstGeom>
+        </p:spPr>
+        <p:style>
+          <a:lnRef idx="2">
+            <a:schemeClr val="accent1">
+              <a:shade val="15000"/>
+            </a:schemeClr>
+          </a:lnRef>
+          <a:fillRef idx="1">
+            <a:schemeClr val="accent1"/>
+          </a:fillRef>
+          <a:effectRef idx="0">
+            <a:schemeClr val="accent1"/>
+          </a:effectRef>
+          <a:fontRef idx="minor">
+            <a:schemeClr val="lt1"/>
+          </a:fontRef>
+        </p:style>
+        <p:txBody>
+          <a:bodyPr rtlCol="0" anchor="ctr"/>
+          <a:lstStyle/>
+          <a:p>
+            <a:pPr algn="ctr"/>
+            <a:r>
+              <a:rPr lang="en-HU" b="1" dirty="0"/>
+              <a:t>ExecuTorch .pte file</a:t>
+            </a:r>
+          </a:p>
+        </p:txBody>
+      </p:sp>
+      <p:cxnSp>
+        <p:nvCxnSpPr>
+          <p:cNvPr id="8" name="Straight Arrow Connector 7">
+            <a:extLst>
+              <a:ext uri="{FF2B5EF4-FFF2-40B4-BE49-F238E27FC236}">
+                <a16:creationId xmlns:a16="http://schemas.microsoft.com/office/drawing/2014/main" id="{E5031318-F604-294C-0571-7C09F1DFC076}"/>
+              </a:ext>
+            </a:extLst>
+          </p:cNvPr>
+          <p:cNvCxnSpPr>
+            <a:cxnSpLocks/>
+            <a:stCxn id="5" idx="2"/>
+            <a:endCxn id="4" idx="0"/>
+          </p:cNvCxnSpPr>
+          <p:nvPr/>
+        </p:nvCxnSpPr>
+        <p:spPr>
+          <a:xfrm>
+            <a:off x="6359555" y="1100388"/>
+            <a:ext cx="2384643" cy="965919"/>
+          </a:xfrm>
+          <a:prstGeom prst="straightConnector1">
+            <a:avLst/>
+          </a:prstGeom>
+          <a:ln>
+            <a:tailEnd type="triangle"/>
+          </a:ln>
+        </p:spPr>
+        <p:style>
+          <a:lnRef idx="3">
+            <a:schemeClr val="dk1"/>
+          </a:lnRef>
+          <a:fillRef idx="0">
+            <a:schemeClr val="dk1"/>
+          </a:fillRef>
+          <a:effectRef idx="2">
+            <a:schemeClr val="dk1"/>
+          </a:effectRef>
+          <a:fontRef idx="minor">
+            <a:schemeClr val="tx1"/>
+          </a:fontRef>
+        </p:style>
+      </p:cxnSp>
+      <p:cxnSp>
+        <p:nvCxnSpPr>
+          <p:cNvPr id="9" name="Straight Arrow Connector 8">
+            <a:extLst>
+              <a:ext uri="{FF2B5EF4-FFF2-40B4-BE49-F238E27FC236}">
+                <a16:creationId xmlns:a16="http://schemas.microsoft.com/office/drawing/2014/main" id="{A737B170-6BC1-0A0E-D398-A3D9E358F1FA}"/>
+              </a:ext>
+            </a:extLst>
+          </p:cNvPr>
+          <p:cNvCxnSpPr>
+            <a:cxnSpLocks/>
+            <a:stCxn id="6" idx="2"/>
+            <a:endCxn id="4" idx="0"/>
+          </p:cNvCxnSpPr>
+          <p:nvPr/>
+        </p:nvCxnSpPr>
+        <p:spPr>
+          <a:xfrm>
+            <a:off x="8722426" y="1100385"/>
+            <a:ext cx="21772" cy="965922"/>
+          </a:xfrm>
+          <a:prstGeom prst="straightConnector1">
+            <a:avLst/>
+          </a:prstGeom>
+          <a:ln>
+            <a:tailEnd type="triangle"/>
+          </a:ln>
+        </p:spPr>
+        <p:style>
+          <a:lnRef idx="3">
+            <a:schemeClr val="dk1"/>
+          </a:lnRef>
+          <a:fillRef idx="0">
+            <a:schemeClr val="dk1"/>
+          </a:fillRef>
+          <a:effectRef idx="2">
+            <a:schemeClr val="dk1"/>
+          </a:effectRef>
+          <a:fontRef idx="minor">
+            <a:schemeClr val="tx1"/>
+          </a:fontRef>
+        </p:style>
+      </p:cxnSp>
+      <p:cxnSp>
+        <p:nvCxnSpPr>
+          <p:cNvPr id="10" name="Straight Arrow Connector 9">
+            <a:extLst>
+              <a:ext uri="{FF2B5EF4-FFF2-40B4-BE49-F238E27FC236}">
+                <a16:creationId xmlns:a16="http://schemas.microsoft.com/office/drawing/2014/main" id="{678590BD-9C21-963B-32CC-A4444FAC021F}"/>
+              </a:ext>
+            </a:extLst>
+          </p:cNvPr>
+          <p:cNvCxnSpPr>
+            <a:cxnSpLocks/>
+            <a:stCxn id="7" idx="2"/>
+            <a:endCxn id="4" idx="0"/>
+          </p:cNvCxnSpPr>
+          <p:nvPr/>
+        </p:nvCxnSpPr>
+        <p:spPr>
+          <a:xfrm flipH="1">
+            <a:off x="8744198" y="1100384"/>
+            <a:ext cx="2269358" cy="965923"/>
+          </a:xfrm>
+          <a:prstGeom prst="straightConnector1">
+            <a:avLst/>
+          </a:prstGeom>
+          <a:ln>
+            <a:tailEnd type="triangle"/>
+          </a:ln>
+        </p:spPr>
+        <p:style>
+          <a:lnRef idx="3">
+            <a:schemeClr val="dk1"/>
+          </a:lnRef>
+          <a:fillRef idx="0">
+            <a:schemeClr val="dk1"/>
+          </a:fillRef>
+          <a:effectRef idx="2">
+            <a:schemeClr val="dk1"/>
+          </a:effectRef>
+          <a:fontRef idx="minor">
+            <a:schemeClr val="tx1"/>
+          </a:fontRef>
+        </p:style>
+      </p:cxnSp>
+      <p:sp>
+        <p:nvSpPr>
+          <p:cNvPr id="11" name="TextBox 10">
+            <a:extLst>
+              <a:ext uri="{FF2B5EF4-FFF2-40B4-BE49-F238E27FC236}">
+                <a16:creationId xmlns:a16="http://schemas.microsoft.com/office/drawing/2014/main" id="{7BF139AB-FCEE-DF72-DDE2-A04F65D2D024}"/>
+              </a:ext>
+            </a:extLst>
+          </p:cNvPr>
+          <p:cNvSpPr txBox="1"/>
+          <p:nvPr/>
+        </p:nvSpPr>
+        <p:spPr>
+          <a:xfrm>
+            <a:off x="5781355" y="1474243"/>
+            <a:ext cx="1584088" cy="369332"/>
+          </a:xfrm>
+          <a:prstGeom prst="rect">
+            <a:avLst/>
+          </a:prstGeom>
+          <a:noFill/>
+        </p:spPr>
+        <p:txBody>
+          <a:bodyPr wrap="none" rtlCol="0">
+            <a:spAutoFit/>
+          </a:bodyPr>
+          <a:lstStyle/>
+          <a:p>
+            <a:r>
+              <a:rPr lang="en-HU" dirty="0"/>
+              <a:t>Model loading</a:t>
+            </a:r>
+          </a:p>
+        </p:txBody>
+      </p:sp>
+      <p:cxnSp>
+        <p:nvCxnSpPr>
+          <p:cNvPr id="12" name="Straight Arrow Connector 11">
+            <a:extLst>
+              <a:ext uri="{FF2B5EF4-FFF2-40B4-BE49-F238E27FC236}">
+                <a16:creationId xmlns:a16="http://schemas.microsoft.com/office/drawing/2014/main" id="{B79422BA-EF98-9A05-4CE4-26934E183A25}"/>
+              </a:ext>
+            </a:extLst>
+          </p:cNvPr>
+          <p:cNvCxnSpPr>
+            <a:cxnSpLocks/>
+            <a:stCxn id="4" idx="2"/>
+            <a:endCxn id="16" idx="0"/>
+          </p:cNvCxnSpPr>
+          <p:nvPr/>
+        </p:nvCxnSpPr>
+        <p:spPr>
+          <a:xfrm flipH="1">
+            <a:off x="6343564" y="3835729"/>
+            <a:ext cx="2400634" cy="402423"/>
+          </a:xfrm>
+          <a:prstGeom prst="straightConnector1">
+            <a:avLst/>
+          </a:prstGeom>
+          <a:ln>
+            <a:tailEnd type="triangle"/>
+          </a:ln>
+        </p:spPr>
+        <p:style>
+          <a:lnRef idx="3">
+            <a:schemeClr val="dk1"/>
+          </a:lnRef>
+          <a:fillRef idx="0">
+            <a:schemeClr val="dk1"/>
+          </a:fillRef>
+          <a:effectRef idx="2">
+            <a:schemeClr val="dk1"/>
+          </a:effectRef>
+          <a:fontRef idx="minor">
+            <a:schemeClr val="tx1"/>
+          </a:fontRef>
+        </p:style>
+      </p:cxnSp>
+      <p:cxnSp>
+        <p:nvCxnSpPr>
+          <p:cNvPr id="13" name="Straight Arrow Connector 12">
+            <a:extLst>
+              <a:ext uri="{FF2B5EF4-FFF2-40B4-BE49-F238E27FC236}">
+                <a16:creationId xmlns:a16="http://schemas.microsoft.com/office/drawing/2014/main" id="{6CD94F81-CD8D-DB49-915F-DFF9BE9D9633}"/>
+              </a:ext>
+            </a:extLst>
+          </p:cNvPr>
+          <p:cNvCxnSpPr>
+            <a:cxnSpLocks/>
+            <a:stCxn id="4" idx="2"/>
+            <a:endCxn id="17" idx="0"/>
+          </p:cNvCxnSpPr>
+          <p:nvPr/>
+        </p:nvCxnSpPr>
+        <p:spPr>
+          <a:xfrm>
+            <a:off x="8744198" y="3835729"/>
+            <a:ext cx="0" cy="418611"/>
+          </a:xfrm>
+          <a:prstGeom prst="straightConnector1">
+            <a:avLst/>
+          </a:prstGeom>
+          <a:ln>
+            <a:tailEnd type="triangle"/>
+          </a:ln>
+        </p:spPr>
+        <p:style>
+          <a:lnRef idx="3">
+            <a:schemeClr val="dk1"/>
+          </a:lnRef>
+          <a:fillRef idx="0">
+            <a:schemeClr val="dk1"/>
+          </a:fillRef>
+          <a:effectRef idx="2">
+            <a:schemeClr val="dk1"/>
+          </a:effectRef>
+          <a:fontRef idx="minor">
+            <a:schemeClr val="tx1"/>
+          </a:fontRef>
+        </p:style>
+      </p:cxnSp>
+      <p:cxnSp>
+        <p:nvCxnSpPr>
+          <p:cNvPr id="14" name="Straight Arrow Connector 13">
+            <a:extLst>
+              <a:ext uri="{FF2B5EF4-FFF2-40B4-BE49-F238E27FC236}">
+                <a16:creationId xmlns:a16="http://schemas.microsoft.com/office/drawing/2014/main" id="{E784C31B-A766-9610-04E6-7E73C5B89017}"/>
+              </a:ext>
+            </a:extLst>
+          </p:cNvPr>
+          <p:cNvCxnSpPr>
+            <a:cxnSpLocks/>
+            <a:stCxn id="4" idx="2"/>
+            <a:endCxn id="18" idx="0"/>
+          </p:cNvCxnSpPr>
+          <p:nvPr/>
+        </p:nvCxnSpPr>
+        <p:spPr>
+          <a:xfrm>
+            <a:off x="8744198" y="3835729"/>
+            <a:ext cx="2422529" cy="418611"/>
+          </a:xfrm>
+          <a:prstGeom prst="straightConnector1">
+            <a:avLst/>
+          </a:prstGeom>
+          <a:ln>
+            <a:tailEnd type="triangle"/>
+          </a:ln>
+        </p:spPr>
+        <p:style>
+          <a:lnRef idx="3">
+            <a:schemeClr val="dk1"/>
+          </a:lnRef>
+          <a:fillRef idx="0">
+            <a:schemeClr val="dk1"/>
+          </a:fillRef>
+          <a:effectRef idx="2">
+            <a:schemeClr val="dk1"/>
+          </a:effectRef>
+          <a:fontRef idx="minor">
+            <a:schemeClr val="tx1"/>
+          </a:fontRef>
+        </p:style>
+      </p:cxnSp>
+      <p:sp>
+        <p:nvSpPr>
+          <p:cNvPr id="15" name="TextBox 14">
+            <a:extLst>
+              <a:ext uri="{FF2B5EF4-FFF2-40B4-BE49-F238E27FC236}">
+                <a16:creationId xmlns:a16="http://schemas.microsoft.com/office/drawing/2014/main" id="{439B3FE9-0CC3-42DD-46CD-A764B11ECDF0}"/>
+              </a:ext>
+            </a:extLst>
+          </p:cNvPr>
+          <p:cNvSpPr txBox="1"/>
+          <p:nvPr/>
+        </p:nvSpPr>
+        <p:spPr>
+          <a:xfrm>
+            <a:off x="8883316" y="3924371"/>
+            <a:ext cx="1124347" cy="369332"/>
+          </a:xfrm>
+          <a:prstGeom prst="rect">
+            <a:avLst/>
+          </a:prstGeom>
+          <a:noFill/>
+        </p:spPr>
+        <p:txBody>
+          <a:bodyPr wrap="none" rtlCol="0">
+            <a:spAutoFit/>
+          </a:bodyPr>
+          <a:lstStyle/>
+          <a:p>
+            <a:r>
+              <a:rPr lang="en-HU" dirty="0"/>
+              <a:t>Inference</a:t>
+            </a:r>
+          </a:p>
+        </p:txBody>
+      </p:sp>
+      <p:sp>
+        <p:nvSpPr>
+          <p:cNvPr id="16" name="Rounded Rectangle 15">
+            <a:extLst>
+              <a:ext uri="{FF2B5EF4-FFF2-40B4-BE49-F238E27FC236}">
+                <a16:creationId xmlns:a16="http://schemas.microsoft.com/office/drawing/2014/main" id="{E0FBF3DF-C1AB-383C-5FF3-3B3484667136}"/>
+              </a:ext>
+            </a:extLst>
+          </p:cNvPr>
+          <p:cNvSpPr/>
+          <p:nvPr/>
+        </p:nvSpPr>
+        <p:spPr>
+          <a:xfrm>
+            <a:off x="5551520" y="4238152"/>
+            <a:ext cx="1584088" cy="814796"/>
+          </a:xfrm>
+          <a:prstGeom prst="roundRect">
+            <a:avLst/>
+          </a:prstGeom>
+        </p:spPr>
+        <p:style>
+          <a:lnRef idx="2">
+            <a:schemeClr val="accent1">
+              <a:shade val="15000"/>
+            </a:schemeClr>
+          </a:lnRef>
+          <a:fillRef idx="1">
+            <a:schemeClr val="accent1"/>
+          </a:fillRef>
+          <a:effectRef idx="0">
+            <a:schemeClr val="accent1"/>
+          </a:effectRef>
+          <a:fontRef idx="minor">
+            <a:schemeClr val="lt1"/>
+          </a:fontRef>
+        </p:style>
+        <p:txBody>
+          <a:bodyPr rtlCol="0" anchor="ctr"/>
+          <a:lstStyle/>
+          <a:p>
+            <a:pPr algn="ctr"/>
+            <a:r>
+              <a:rPr lang="en-HU" b="1" dirty="0"/>
+              <a:t>ONNX Runtime</a:t>
+            </a:r>
+          </a:p>
+        </p:txBody>
+      </p:sp>
+      <p:sp>
+        <p:nvSpPr>
+          <p:cNvPr id="17" name="Rounded Rectangle 16">
+            <a:extLst>
+              <a:ext uri="{FF2B5EF4-FFF2-40B4-BE49-F238E27FC236}">
+                <a16:creationId xmlns:a16="http://schemas.microsoft.com/office/drawing/2014/main" id="{E4CDD73E-68F5-E453-F1B7-C2EAE760A620}"/>
+              </a:ext>
+            </a:extLst>
+          </p:cNvPr>
+          <p:cNvSpPr/>
+          <p:nvPr/>
+        </p:nvSpPr>
+        <p:spPr>
+          <a:xfrm>
+            <a:off x="7901633" y="4254340"/>
+            <a:ext cx="1685130" cy="814796"/>
+          </a:xfrm>
+          <a:prstGeom prst="roundRect">
+            <a:avLst/>
+          </a:prstGeom>
+        </p:spPr>
+        <p:style>
+          <a:lnRef idx="2">
+            <a:schemeClr val="accent1">
+              <a:shade val="15000"/>
+            </a:schemeClr>
+          </a:lnRef>
+          <a:fillRef idx="1">
+            <a:schemeClr val="accent1"/>
+          </a:fillRef>
+          <a:effectRef idx="0">
+            <a:schemeClr val="accent1"/>
+          </a:effectRef>
+          <a:fontRef idx="minor">
+            <a:schemeClr val="lt1"/>
+          </a:fontRef>
+        </p:style>
+        <p:txBody>
+          <a:bodyPr rtlCol="0" anchor="ctr"/>
+          <a:lstStyle/>
+          <a:p>
+            <a:pPr algn="ctr"/>
+            <a:r>
+              <a:rPr lang="en-HU" b="1" dirty="0"/>
+              <a:t>HailoRT</a:t>
+            </a:r>
+          </a:p>
+        </p:txBody>
+      </p:sp>
+      <p:sp>
+        <p:nvSpPr>
+          <p:cNvPr id="18" name="Rounded Rectangle 17">
+            <a:extLst>
+              <a:ext uri="{FF2B5EF4-FFF2-40B4-BE49-F238E27FC236}">
+                <a16:creationId xmlns:a16="http://schemas.microsoft.com/office/drawing/2014/main" id="{84E867F6-F8EA-0C3F-E43F-5158257BFCD1}"/>
+              </a:ext>
+            </a:extLst>
+          </p:cNvPr>
+          <p:cNvSpPr/>
+          <p:nvPr/>
+        </p:nvSpPr>
+        <p:spPr>
+          <a:xfrm>
+            <a:off x="10428563" y="4254340"/>
+            <a:ext cx="1476327" cy="798604"/>
+          </a:xfrm>
+          <a:prstGeom prst="roundRect">
+            <a:avLst/>
+          </a:prstGeom>
+        </p:spPr>
+        <p:style>
+          <a:lnRef idx="2">
+            <a:schemeClr val="accent1">
+              <a:shade val="15000"/>
+            </a:schemeClr>
+          </a:lnRef>
+          <a:fillRef idx="1">
+            <a:schemeClr val="accent1"/>
+          </a:fillRef>
+          <a:effectRef idx="0">
+            <a:schemeClr val="accent1"/>
+          </a:effectRef>
+          <a:fontRef idx="minor">
+            <a:schemeClr val="lt1"/>
+          </a:fontRef>
+        </p:style>
+        <p:txBody>
+          <a:bodyPr rtlCol="0" anchor="ctr"/>
+          <a:lstStyle/>
+          <a:p>
+            <a:pPr algn="ctr"/>
+            <a:r>
+              <a:rPr lang="en-HU" b="1" dirty="0"/>
+              <a:t>ExecuTorch</a:t>
+            </a:r>
+          </a:p>
+        </p:txBody>
+      </p:sp>
+      <p:sp>
+        <p:nvSpPr>
+          <p:cNvPr id="19" name="Rectangle 18">
+            <a:extLst>
+              <a:ext uri="{FF2B5EF4-FFF2-40B4-BE49-F238E27FC236}">
+                <a16:creationId xmlns:a16="http://schemas.microsoft.com/office/drawing/2014/main" id="{BED7107D-F1B6-404C-A179-10C74ADE3BBE}"/>
+              </a:ext>
+            </a:extLst>
+          </p:cNvPr>
+          <p:cNvSpPr/>
+          <p:nvPr/>
+        </p:nvSpPr>
+        <p:spPr>
+          <a:xfrm>
+            <a:off x="365667" y="1217587"/>
+            <a:ext cx="4851498" cy="5527597"/>
+          </a:xfrm>
+          <a:prstGeom prst="rect">
+            <a:avLst/>
+          </a:prstGeom>
+          <a:solidFill>
+            <a:schemeClr val="bg2">
+              <a:lumMod val="75000"/>
+            </a:schemeClr>
+          </a:solidFill>
+          <a:ln>
+            <a:solidFill>
+              <a:schemeClr val="tx1"/>
+            </a:solidFill>
+          </a:ln>
+        </p:spPr>
+        <p:style>
+          <a:lnRef idx="2">
+            <a:schemeClr val="accent1">
+              <a:shade val="15000"/>
+            </a:schemeClr>
+          </a:lnRef>
+          <a:fillRef idx="1">
+            <a:schemeClr val="accent1"/>
+          </a:fillRef>
+          <a:effectRef idx="0">
+            <a:schemeClr val="accent1"/>
+          </a:effectRef>
+          <a:fontRef idx="minor">
+            <a:schemeClr val="lt1"/>
+          </a:fontRef>
+        </p:style>
+        <p:txBody>
+          <a:bodyPr rtlCol="0" anchor="ctr"/>
+          <a:lstStyle/>
+          <a:p>
+            <a:pPr algn="ctr"/>
+            <a:endParaRPr lang="en-HU" b="1" dirty="0">
+              <a:solidFill>
+                <a:schemeClr val="tx1"/>
+              </a:solidFill>
+              <a:latin typeface="Consolas" panose="020B0609020204030204" pitchFamily="49" charset="0"/>
+              <a:cs typeface="Consolas" panose="020B0609020204030204" pitchFamily="49" charset="0"/>
+            </a:endParaRPr>
+          </a:p>
+          <a:p>
+            <a:pPr algn="ctr"/>
+            <a:r>
+              <a:rPr lang="en-HU" b="1" dirty="0">
+                <a:solidFill>
+                  <a:schemeClr val="tx1"/>
+                </a:solidFill>
+                <a:cs typeface="Consolas" panose="020B0609020204030204" pitchFamily="49" charset="0"/>
+              </a:rPr>
+              <a:t>ONNX Runtime</a:t>
+            </a:r>
+            <a:r>
+              <a:rPr lang="en-HU" dirty="0">
+                <a:solidFill>
+                  <a:schemeClr val="tx1"/>
+                </a:solidFill>
+                <a:cs typeface="Consolas" panose="020B0609020204030204" pitchFamily="49" charset="0"/>
+              </a:rPr>
+              <a:t>: our current in-pipeline inference</a:t>
+            </a:r>
+          </a:p>
+          <a:p>
+            <a:pPr algn="ctr"/>
+            <a:endParaRPr lang="en-HU" dirty="0">
+              <a:solidFill>
+                <a:schemeClr val="tx1"/>
+              </a:solidFill>
+              <a:cs typeface="Consolas" panose="020B0609020204030204" pitchFamily="49" charset="0"/>
+            </a:endParaRPr>
+          </a:p>
+          <a:p>
+            <a:pPr algn="ctr"/>
+            <a:r>
+              <a:rPr lang="en-HU" b="1" dirty="0">
+                <a:solidFill>
+                  <a:schemeClr val="tx1"/>
+                </a:solidFill>
+                <a:cs typeface="Consolas" panose="020B0609020204030204" pitchFamily="49" charset="0"/>
+              </a:rPr>
+              <a:t>HailoRT</a:t>
+            </a:r>
+            <a:r>
+              <a:rPr lang="en-HU" dirty="0">
+                <a:solidFill>
+                  <a:schemeClr val="tx1"/>
+                </a:solidFill>
+                <a:cs typeface="Consolas" panose="020B0609020204030204" pitchFamily="49" charset="0"/>
+              </a:rPr>
+              <a:t>: hardware accelerated inference on Raspberry PI 5, currently under integration</a:t>
+            </a:r>
+          </a:p>
+          <a:p>
+            <a:pPr algn="ctr"/>
+            <a:endParaRPr lang="en-HU" dirty="0">
+              <a:solidFill>
+                <a:schemeClr val="tx1"/>
+              </a:solidFill>
+              <a:cs typeface="Consolas" panose="020B0609020204030204" pitchFamily="49" charset="0"/>
+            </a:endParaRPr>
+          </a:p>
+          <a:p>
+            <a:pPr algn="ctr"/>
+            <a:r>
+              <a:rPr lang="en-HU" b="1" dirty="0">
+                <a:solidFill>
+                  <a:schemeClr val="tx1"/>
+                </a:solidFill>
+                <a:cs typeface="Consolas" panose="020B0609020204030204" pitchFamily="49" charset="0"/>
+              </a:rPr>
+              <a:t>ExecuTorch</a:t>
+            </a:r>
+            <a:r>
+              <a:rPr lang="en-HU" dirty="0">
+                <a:solidFill>
+                  <a:schemeClr val="tx1"/>
+                </a:solidFill>
+                <a:cs typeface="Consolas" panose="020B0609020204030204" pitchFamily="49" charset="0"/>
+              </a:rPr>
+              <a:t>: new engine, maybe our default in the future, integration in Q2</a:t>
+            </a:r>
+          </a:p>
+          <a:p>
+            <a:pPr algn="ctr"/>
+            <a:endParaRPr lang="en-HU" dirty="0">
+              <a:solidFill>
+                <a:schemeClr val="tx1"/>
+              </a:solidFill>
+              <a:cs typeface="Consolas" panose="020B0609020204030204" pitchFamily="49" charset="0"/>
+            </a:endParaRPr>
+          </a:p>
+          <a:p>
+            <a:pPr algn="ctr"/>
+            <a:r>
+              <a:rPr lang="en-HU" b="1" dirty="0">
+                <a:solidFill>
+                  <a:schemeClr val="tx1"/>
+                </a:solidFill>
+                <a:cs typeface="Consolas" panose="020B0609020204030204" pitchFamily="49" charset="0"/>
+              </a:rPr>
+              <a:t>FEATURES</a:t>
+            </a:r>
+          </a:p>
+          <a:p>
+            <a:pPr algn="ctr"/>
+            <a:endParaRPr lang="en-HU" dirty="0">
+              <a:solidFill>
+                <a:schemeClr val="tx1"/>
+              </a:solidFill>
+              <a:cs typeface="Consolas" panose="020B0609020204030204" pitchFamily="49" charset="0"/>
+            </a:endParaRPr>
+          </a:p>
+          <a:p>
+            <a:pPr algn="ctr"/>
+            <a:r>
+              <a:rPr lang="en-HU" b="1" dirty="0">
+                <a:solidFill>
+                  <a:schemeClr val="tx1"/>
+                </a:solidFill>
+                <a:cs typeface="Consolas" panose="020B0609020204030204" pitchFamily="49" charset="0"/>
+              </a:rPr>
+              <a:t>Configurable</a:t>
+            </a:r>
+            <a:r>
+              <a:rPr lang="en-HU" dirty="0">
+                <a:solidFill>
+                  <a:schemeClr val="tx1"/>
+                </a:solidFill>
+                <a:cs typeface="Consolas" panose="020B0609020204030204" pitchFamily="49" charset="0"/>
+              </a:rPr>
+              <a:t> model handling (via model meta JSON files)</a:t>
+            </a:r>
+          </a:p>
+          <a:p>
+            <a:pPr algn="ctr"/>
+            <a:endParaRPr lang="en-HU" dirty="0">
+              <a:solidFill>
+                <a:schemeClr val="tx1"/>
+              </a:solidFill>
+              <a:cs typeface="Consolas" panose="020B0609020204030204" pitchFamily="49" charset="0"/>
+            </a:endParaRPr>
+          </a:p>
+          <a:p>
+            <a:pPr algn="ctr"/>
+            <a:r>
+              <a:rPr lang="en-HU" b="1" dirty="0">
+                <a:solidFill>
+                  <a:schemeClr val="tx1"/>
+                </a:solidFill>
+                <a:cs typeface="Consolas" panose="020B0609020204030204" pitchFamily="49" charset="0"/>
+              </a:rPr>
+              <a:t>Modularized</a:t>
+            </a:r>
+            <a:r>
+              <a:rPr lang="en-HU" dirty="0">
+                <a:solidFill>
+                  <a:schemeClr val="tx1"/>
+                </a:solidFill>
+                <a:cs typeface="Consolas" panose="020B0609020204030204" pitchFamily="49" charset="0"/>
+              </a:rPr>
+              <a:t>, easy to add/remove features</a:t>
+            </a:r>
+          </a:p>
+          <a:p>
+            <a:pPr algn="ctr"/>
+            <a:endParaRPr lang="en-HU" dirty="0">
+              <a:solidFill>
+                <a:schemeClr val="tx1"/>
+              </a:solidFill>
+              <a:cs typeface="Consolas" panose="020B0609020204030204" pitchFamily="49" charset="0"/>
+            </a:endParaRPr>
+          </a:p>
+          <a:p>
+            <a:pPr algn="ctr"/>
+            <a:r>
+              <a:rPr lang="en-HU" dirty="0">
+                <a:solidFill>
+                  <a:schemeClr val="tx1"/>
+                </a:solidFill>
+                <a:cs typeface="Consolas" panose="020B0609020204030204" pitchFamily="49" charset="0"/>
+              </a:rPr>
+              <a:t>Standardized </a:t>
+            </a:r>
+            <a:r>
+              <a:rPr lang="en-HU" b="1" dirty="0">
+                <a:solidFill>
+                  <a:schemeClr val="tx1"/>
+                </a:solidFill>
+                <a:cs typeface="Consolas" panose="020B0609020204030204" pitchFamily="49" charset="0"/>
+              </a:rPr>
+              <a:t>preprocessors</a:t>
+            </a:r>
+            <a:r>
+              <a:rPr lang="en-HU" dirty="0">
+                <a:solidFill>
+                  <a:schemeClr val="tx1"/>
+                </a:solidFill>
+                <a:cs typeface="Consolas" panose="020B0609020204030204" pitchFamily="49" charset="0"/>
+              </a:rPr>
+              <a:t> and </a:t>
+            </a:r>
+            <a:r>
+              <a:rPr lang="en-HU" b="1" dirty="0">
+                <a:solidFill>
+                  <a:schemeClr val="tx1"/>
+                </a:solidFill>
+                <a:cs typeface="Consolas" panose="020B0609020204030204" pitchFamily="49" charset="0"/>
+              </a:rPr>
+              <a:t>postprocessors</a:t>
+            </a:r>
+          </a:p>
+          <a:p>
+            <a:pPr algn="ctr"/>
+            <a:endParaRPr lang="en-HU" dirty="0">
+              <a:solidFill>
+                <a:schemeClr val="tx1"/>
+              </a:solidFill>
+              <a:cs typeface="Consolas" panose="020B0609020204030204" pitchFamily="49" charset="0"/>
+            </a:endParaRPr>
+          </a:p>
+          <a:p>
+            <a:pPr algn="ctr"/>
+            <a:r>
+              <a:rPr lang="en-HU" b="1" dirty="0">
+                <a:solidFill>
+                  <a:schemeClr val="tx1"/>
+                </a:solidFill>
+                <a:cs typeface="Consolas" panose="020B0609020204030204" pitchFamily="49" charset="0"/>
+              </a:rPr>
+              <a:t>Quantization-agnostic</a:t>
+            </a:r>
+            <a:r>
+              <a:rPr lang="en-HU" dirty="0">
+                <a:solidFill>
+                  <a:schemeClr val="tx1"/>
+                </a:solidFill>
+                <a:cs typeface="Consolas" panose="020B0609020204030204" pitchFamily="49" charset="0"/>
+              </a:rPr>
+              <a:t> code and APIs</a:t>
+            </a:r>
+          </a:p>
+          <a:p>
+            <a:pPr algn="ctr"/>
+            <a:endParaRPr lang="en-HU" b="1" u="sng" dirty="0">
+              <a:solidFill>
+                <a:schemeClr val="tx1"/>
+              </a:solidFill>
+              <a:latin typeface="Consolas" panose="020B0609020204030204" pitchFamily="49" charset="0"/>
+              <a:cs typeface="Consolas" panose="020B0609020204030204" pitchFamily="49" charset="0"/>
+            </a:endParaRPr>
+          </a:p>
+        </p:txBody>
+      </p:sp>
+      <p:cxnSp>
+        <p:nvCxnSpPr>
+          <p:cNvPr id="20" name="Straight Arrow Connector 19">
+            <a:extLst>
+              <a:ext uri="{FF2B5EF4-FFF2-40B4-BE49-F238E27FC236}">
+                <a16:creationId xmlns:a16="http://schemas.microsoft.com/office/drawing/2014/main" id="{0DF143B9-3749-487F-C0BC-3B8682187316}"/>
+              </a:ext>
+            </a:extLst>
+          </p:cNvPr>
+          <p:cNvCxnSpPr>
+            <a:cxnSpLocks/>
+            <a:stCxn id="16" idx="2"/>
+            <a:endCxn id="23" idx="0"/>
+          </p:cNvCxnSpPr>
+          <p:nvPr/>
+        </p:nvCxnSpPr>
+        <p:spPr>
+          <a:xfrm>
+            <a:off x="6343564" y="5052948"/>
+            <a:ext cx="2400634" cy="653656"/>
+          </a:xfrm>
+          <a:prstGeom prst="straightConnector1">
+            <a:avLst/>
+          </a:prstGeom>
+          <a:ln>
+            <a:tailEnd type="triangle"/>
+          </a:ln>
+        </p:spPr>
+        <p:style>
+          <a:lnRef idx="3">
+            <a:schemeClr val="dk1"/>
+          </a:lnRef>
+          <a:fillRef idx="0">
+            <a:schemeClr val="dk1"/>
+          </a:fillRef>
+          <a:effectRef idx="2">
+            <a:schemeClr val="dk1"/>
+          </a:effectRef>
+          <a:fontRef idx="minor">
+            <a:schemeClr val="tx1"/>
+          </a:fontRef>
+        </p:style>
+      </p:cxnSp>
+      <p:cxnSp>
+        <p:nvCxnSpPr>
+          <p:cNvPr id="21" name="Straight Arrow Connector 20">
+            <a:extLst>
+              <a:ext uri="{FF2B5EF4-FFF2-40B4-BE49-F238E27FC236}">
+                <a16:creationId xmlns:a16="http://schemas.microsoft.com/office/drawing/2014/main" id="{7EAE7024-F2AB-D4C1-723C-56EFBD39F634}"/>
+              </a:ext>
+            </a:extLst>
+          </p:cNvPr>
+          <p:cNvCxnSpPr>
+            <a:cxnSpLocks/>
+            <a:stCxn id="17" idx="2"/>
+            <a:endCxn id="23" idx="0"/>
+          </p:cNvCxnSpPr>
+          <p:nvPr/>
+        </p:nvCxnSpPr>
+        <p:spPr>
+          <a:xfrm>
+            <a:off x="8744198" y="5069136"/>
+            <a:ext cx="0" cy="637468"/>
+          </a:xfrm>
+          <a:prstGeom prst="straightConnector1">
+            <a:avLst/>
+          </a:prstGeom>
+          <a:ln>
+            <a:tailEnd type="triangle"/>
+          </a:ln>
+        </p:spPr>
+        <p:style>
+          <a:lnRef idx="3">
+            <a:schemeClr val="dk1"/>
+          </a:lnRef>
+          <a:fillRef idx="0">
+            <a:schemeClr val="dk1"/>
+          </a:fillRef>
+          <a:effectRef idx="2">
+            <a:schemeClr val="dk1"/>
+          </a:effectRef>
+          <a:fontRef idx="minor">
+            <a:schemeClr val="tx1"/>
+          </a:fontRef>
+        </p:style>
+      </p:cxnSp>
+      <p:cxnSp>
+        <p:nvCxnSpPr>
+          <p:cNvPr id="22" name="Straight Arrow Connector 21">
+            <a:extLst>
+              <a:ext uri="{FF2B5EF4-FFF2-40B4-BE49-F238E27FC236}">
+                <a16:creationId xmlns:a16="http://schemas.microsoft.com/office/drawing/2014/main" id="{2B75F310-942F-A179-0256-16A947AB72B5}"/>
+              </a:ext>
+            </a:extLst>
+          </p:cNvPr>
+          <p:cNvCxnSpPr>
+            <a:cxnSpLocks/>
+            <a:stCxn id="18" idx="2"/>
+            <a:endCxn id="23" idx="0"/>
+          </p:cNvCxnSpPr>
+          <p:nvPr/>
+        </p:nvCxnSpPr>
+        <p:spPr>
+          <a:xfrm flipH="1">
+            <a:off x="8744198" y="5052944"/>
+            <a:ext cx="2422529" cy="653660"/>
+          </a:xfrm>
+          <a:prstGeom prst="straightConnector1">
+            <a:avLst/>
+          </a:prstGeom>
+          <a:ln>
+            <a:tailEnd type="triangle"/>
+          </a:ln>
+        </p:spPr>
+        <p:style>
+          <a:lnRef idx="3">
+            <a:schemeClr val="dk1"/>
+          </a:lnRef>
+          <a:fillRef idx="0">
+            <a:schemeClr val="dk1"/>
+          </a:fillRef>
+          <a:effectRef idx="2">
+            <a:schemeClr val="dk1"/>
+          </a:effectRef>
+          <a:fontRef idx="minor">
+            <a:schemeClr val="tx1"/>
+          </a:fontRef>
+        </p:style>
+      </p:cxnSp>
+      <p:sp>
+        <p:nvSpPr>
+          <p:cNvPr id="23" name="Rounded Rectangle 22">
+            <a:extLst>
+              <a:ext uri="{FF2B5EF4-FFF2-40B4-BE49-F238E27FC236}">
+                <a16:creationId xmlns:a16="http://schemas.microsoft.com/office/drawing/2014/main" id="{5AEA8314-6DA3-2A72-E50C-90D750BB1DDD}"/>
+              </a:ext>
+            </a:extLst>
+          </p:cNvPr>
+          <p:cNvSpPr/>
+          <p:nvPr/>
+        </p:nvSpPr>
+        <p:spPr>
+          <a:xfrm>
+            <a:off x="6772344" y="5706604"/>
+            <a:ext cx="3943707" cy="814796"/>
+          </a:xfrm>
+          <a:prstGeom prst="roundRect">
+            <a:avLst/>
+          </a:prstGeom>
+          <a:solidFill>
+            <a:schemeClr val="accent6">
+              <a:lumMod val="75000"/>
+            </a:schemeClr>
+          </a:solidFill>
+        </p:spPr>
+        <p:style>
+          <a:lnRef idx="2">
+            <a:schemeClr val="accent1">
+              <a:shade val="15000"/>
+            </a:schemeClr>
+          </a:lnRef>
+          <a:fillRef idx="1">
+            <a:schemeClr val="accent1"/>
+          </a:fillRef>
+          <a:effectRef idx="0">
+            <a:schemeClr val="accent1"/>
+          </a:effectRef>
+          <a:fontRef idx="minor">
+            <a:schemeClr val="lt1"/>
+          </a:fontRef>
+        </p:style>
+        <p:txBody>
+          <a:bodyPr rtlCol="0" anchor="ctr"/>
+          <a:lstStyle/>
+          <a:p>
+            <a:pPr algn="ctr"/>
+            <a:r>
+              <a:rPr lang="en-HU" b="1" dirty="0"/>
+              <a:t>Inference result metadata</a:t>
+            </a:r>
+          </a:p>
+          <a:p>
+            <a:pPr algn="ctr"/>
+            <a:r>
+              <a:rPr lang="en-HU" sz="1400" dirty="0"/>
+              <a:t>API agnostic</a:t>
+            </a:r>
+          </a:p>
+          <a:p>
+            <a:pPr algn="ctr"/>
+            <a:r>
+              <a:rPr lang="en-HU" sz="1400" dirty="0"/>
+              <a:t>Simple user-friendly: bounding boxes, text, etc.</a:t>
+            </a:r>
+          </a:p>
+        </p:txBody>
+      </p:sp>
+      <p:sp>
+        <p:nvSpPr>
+          <p:cNvPr id="24" name="TextBox 23">
+            <a:extLst>
+              <a:ext uri="{FF2B5EF4-FFF2-40B4-BE49-F238E27FC236}">
+                <a16:creationId xmlns:a16="http://schemas.microsoft.com/office/drawing/2014/main" id="{206F6897-5069-050E-5F73-2691BD4FE637}"/>
+              </a:ext>
+            </a:extLst>
+          </p:cNvPr>
+          <p:cNvSpPr txBox="1"/>
+          <p:nvPr/>
+        </p:nvSpPr>
+        <p:spPr>
+          <a:xfrm>
+            <a:off x="5564155" y="5235819"/>
+            <a:ext cx="1713611" cy="369332"/>
+          </a:xfrm>
+          <a:prstGeom prst="rect">
+            <a:avLst/>
+          </a:prstGeom>
+          <a:noFill/>
+        </p:spPr>
+        <p:txBody>
+          <a:bodyPr wrap="none" rtlCol="0">
+            <a:spAutoFit/>
+          </a:bodyPr>
+          <a:lstStyle/>
+          <a:p>
+            <a:r>
+              <a:rPr lang="en-HU" dirty="0"/>
+              <a:t>Postprocessing</a:t>
+            </a:r>
+          </a:p>
+        </p:txBody>
+      </p:sp>
+      <p:sp>
+        <p:nvSpPr>
+          <p:cNvPr id="25" name="TextBox 24">
+            <a:extLst>
+              <a:ext uri="{FF2B5EF4-FFF2-40B4-BE49-F238E27FC236}">
+                <a16:creationId xmlns:a16="http://schemas.microsoft.com/office/drawing/2014/main" id="{D9604B37-B592-5D64-16F0-B918A0F4BD49}"/>
+              </a:ext>
+            </a:extLst>
+          </p:cNvPr>
+          <p:cNvSpPr txBox="1"/>
+          <p:nvPr/>
+        </p:nvSpPr>
+        <p:spPr>
+          <a:xfrm>
+            <a:off x="561072" y="17257"/>
+            <a:ext cx="4496773" cy="1200329"/>
+          </a:xfrm>
+          <a:prstGeom prst="rect">
+            <a:avLst/>
+          </a:prstGeom>
+          <a:noFill/>
+        </p:spPr>
+        <p:txBody>
+          <a:bodyPr wrap="square" rtlCol="0">
+            <a:spAutoFit/>
+          </a:bodyPr>
+          <a:lstStyle/>
+          <a:p>
+            <a:pPr algn="ctr"/>
+            <a:r>
+              <a:rPr lang="en-HU" sz="3600" b="1" dirty="0">
+                <a:latin typeface="Consolas" panose="020B0609020204030204" pitchFamily="49" charset="0"/>
+                <a:cs typeface="Consolas" panose="020B0609020204030204" pitchFamily="49" charset="0"/>
+              </a:rPr>
+              <a:t>Inference Engine Abstraction</a:t>
+            </a:r>
+          </a:p>
+        </p:txBody>
+      </p:sp>
+    </p:spTree>
+    <p:extLst>
+      <p:ext uri="{BB962C8B-B14F-4D97-AF65-F5344CB8AC3E}">
+        <p14:creationId xmlns:p14="http://schemas.microsoft.com/office/powerpoint/2010/main" val="1085443662"/>
+      </p:ext>
+    </p:extLst>
+  </p:cSld>
+  <p:clrMapOvr>
+    <a:masterClrMapping/>
+  </p:clrMapOvr>
+</p:sld>
+</file>
+
+<file path=ppt/slides/slide5.xml><?xml version="1.0" encoding="utf-8"?>
+<p:sld xmlns:a="http://schemas.openxmlformats.org/drawingml/2006/main" xmlns:r="http://schemas.openxmlformats.org/officeDocument/2006/relationships" xmlns:p="http://schemas.openxmlformats.org/presentationml/2006/main">
+  <p:cSld>
+    <p:spTree>
+      <p:nvGrpSpPr>
+        <p:cNvPr id="1" name=""/>
+        <p:cNvGrpSpPr/>
+        <p:nvPr/>
+      </p:nvGrpSpPr>
+      <p:grpSpPr>
+        <a:xfrm>
+          <a:off x="0" y="0"/>
+          <a:ext cx="0" cy="0"/>
+          <a:chOff x="0" y="0"/>
+          <a:chExt cx="0" cy="0"/>
+        </a:xfrm>
+      </p:grpSpPr>
+      <p:sp>
+        <p:nvSpPr>
+          <p:cNvPr id="4" name="TextBox 3">
+            <a:extLst>
+              <a:ext uri="{FF2B5EF4-FFF2-40B4-BE49-F238E27FC236}">
+                <a16:creationId xmlns:a16="http://schemas.microsoft.com/office/drawing/2014/main" id="{022A4883-7906-8A6A-F332-B60FE81DA46D}"/>
+              </a:ext>
+            </a:extLst>
+          </p:cNvPr>
+          <p:cNvSpPr txBox="1"/>
+          <p:nvPr/>
+        </p:nvSpPr>
+        <p:spPr>
+          <a:xfrm>
+            <a:off x="3391201" y="161719"/>
+            <a:ext cx="5687420" cy="646331"/>
+          </a:xfrm>
+          <a:prstGeom prst="rect">
+            <a:avLst/>
+          </a:prstGeom>
+          <a:noFill/>
+        </p:spPr>
+        <p:txBody>
+          <a:bodyPr wrap="square" rtlCol="0">
+            <a:spAutoFit/>
+          </a:bodyPr>
+          <a:lstStyle/>
+          <a:p>
+            <a:pPr algn="ctr"/>
+            <a:r>
+              <a:rPr lang="en-HU" sz="3600" b="1" dirty="0">
+                <a:latin typeface="Consolas" panose="020B0609020204030204" pitchFamily="49" charset="0"/>
+                <a:cs typeface="Consolas" panose="020B0609020204030204" pitchFamily="49" charset="0"/>
+              </a:rPr>
+              <a:t>Bring Your Own Model</a:t>
+            </a:r>
+          </a:p>
+        </p:txBody>
+      </p:sp>
+      <p:sp>
+        <p:nvSpPr>
+          <p:cNvPr id="5" name="TextBox 4">
+            <a:extLst>
+              <a:ext uri="{FF2B5EF4-FFF2-40B4-BE49-F238E27FC236}">
+                <a16:creationId xmlns:a16="http://schemas.microsoft.com/office/drawing/2014/main" id="{C28AB284-88DF-0621-AA5C-C638D87782E1}"/>
+              </a:ext>
+            </a:extLst>
+          </p:cNvPr>
+          <p:cNvSpPr txBox="1"/>
+          <p:nvPr/>
+        </p:nvSpPr>
+        <p:spPr>
+          <a:xfrm>
+            <a:off x="831788" y="808050"/>
+            <a:ext cx="5545777" cy="1477328"/>
+          </a:xfrm>
+          <a:prstGeom prst="rect">
+            <a:avLst/>
+          </a:prstGeom>
+          <a:noFill/>
+        </p:spPr>
+        <p:txBody>
+          <a:bodyPr wrap="square" rtlCol="0">
+            <a:spAutoFit/>
+          </a:bodyPr>
+          <a:lstStyle/>
+          <a:p>
+            <a:r>
+              <a:rPr lang="en-HU" b="1" dirty="0"/>
+              <a:t>Requirements</a:t>
+            </a:r>
+          </a:p>
+          <a:p>
+            <a:pPr marL="285750" indent="-285750">
+              <a:buFontTx/>
+              <a:buChar char="-"/>
+            </a:pPr>
+            <a:r>
+              <a:rPr lang="en-HU" dirty="0"/>
+              <a:t>Often appears as a required feature</a:t>
+            </a:r>
+          </a:p>
+          <a:p>
+            <a:pPr marL="285750" indent="-285750">
+              <a:buFontTx/>
+              <a:buChar char="-"/>
+            </a:pPr>
+            <a:r>
+              <a:rPr lang="en-HU" dirty="0"/>
+              <a:t>Rarely mentioned that models need custom postprocessing</a:t>
+            </a:r>
+          </a:p>
+          <a:p>
+            <a:pPr marL="285750" indent="-285750">
+              <a:buFontTx/>
+              <a:buChar char="-"/>
+            </a:pPr>
+            <a:r>
+              <a:rPr lang="en-HU" dirty="0"/>
+              <a:t>How to support non-developers?</a:t>
+            </a:r>
+          </a:p>
+        </p:txBody>
+      </p:sp>
+      <p:sp>
+        <p:nvSpPr>
+          <p:cNvPr id="6" name="TextBox 5">
+            <a:extLst>
+              <a:ext uri="{FF2B5EF4-FFF2-40B4-BE49-F238E27FC236}">
+                <a16:creationId xmlns:a16="http://schemas.microsoft.com/office/drawing/2014/main" id="{B80F411B-4A13-7F3D-917F-A3FC1E5059DB}"/>
+              </a:ext>
+            </a:extLst>
+          </p:cNvPr>
+          <p:cNvSpPr txBox="1"/>
+          <p:nvPr/>
+        </p:nvSpPr>
+        <p:spPr>
+          <a:xfrm>
+            <a:off x="831787" y="2338144"/>
+            <a:ext cx="5545777" cy="1477328"/>
+          </a:xfrm>
+          <a:prstGeom prst="rect">
+            <a:avLst/>
+          </a:prstGeom>
+          <a:noFill/>
+        </p:spPr>
+        <p:txBody>
+          <a:bodyPr wrap="square" rtlCol="0">
+            <a:spAutoFit/>
+          </a:bodyPr>
+          <a:lstStyle/>
+          <a:p>
+            <a:r>
+              <a:rPr lang="en-HU" b="1" dirty="0"/>
+              <a:t>Features that support this</a:t>
+            </a:r>
+          </a:p>
+          <a:p>
+            <a:pPr marL="285750" indent="-285750">
+              <a:buFontTx/>
+              <a:buChar char="-"/>
+            </a:pPr>
+            <a:r>
+              <a:rPr lang="en-HU" dirty="0"/>
+              <a:t>Versatile, configurable pre-written postprocessors to support model-family outputs</a:t>
+            </a:r>
+          </a:p>
+          <a:p>
+            <a:pPr marL="285750" indent="-285750">
+              <a:buFontTx/>
+              <a:buChar char="-"/>
+            </a:pPr>
+            <a:r>
+              <a:rPr lang="en-HU" dirty="0"/>
+              <a:t>Simple interfaces to implement custom postprocessors</a:t>
+            </a:r>
+          </a:p>
+        </p:txBody>
+      </p:sp>
+      <p:sp>
+        <p:nvSpPr>
+          <p:cNvPr id="7" name="TextBox 6">
+            <a:extLst>
+              <a:ext uri="{FF2B5EF4-FFF2-40B4-BE49-F238E27FC236}">
+                <a16:creationId xmlns:a16="http://schemas.microsoft.com/office/drawing/2014/main" id="{B0EF0875-8081-AF59-8403-EF11F65C581C}"/>
+              </a:ext>
+            </a:extLst>
+          </p:cNvPr>
+          <p:cNvSpPr txBox="1"/>
+          <p:nvPr/>
+        </p:nvSpPr>
+        <p:spPr>
+          <a:xfrm>
+            <a:off x="831786" y="3902062"/>
+            <a:ext cx="5545777" cy="2585323"/>
+          </a:xfrm>
+          <a:prstGeom prst="rect">
+            <a:avLst/>
+          </a:prstGeom>
+          <a:noFill/>
+        </p:spPr>
+        <p:txBody>
+          <a:bodyPr wrap="square" rtlCol="0">
+            <a:spAutoFit/>
+          </a:bodyPr>
+          <a:lstStyle/>
+          <a:p>
+            <a:r>
+              <a:rPr lang="en-HU" b="1" dirty="0"/>
+              <a:t>Python interface</a:t>
+            </a:r>
+          </a:p>
+          <a:p>
+            <a:pPr marL="285750" indent="-285750">
+              <a:buFontTx/>
+              <a:buChar char="-"/>
+            </a:pPr>
+            <a:r>
+              <a:rPr lang="en-HU" dirty="0"/>
+              <a:t>An interface that calls into Python code when postprocessing needed</a:t>
+            </a:r>
+          </a:p>
+          <a:p>
+            <a:pPr marL="285750" indent="-285750">
+              <a:buFontTx/>
+              <a:buChar char="-"/>
+            </a:pPr>
+            <a:r>
+              <a:rPr lang="en-HU" dirty="0"/>
+              <a:t>C++ provides the output tensor to Python, Python produces the detection metadata</a:t>
+            </a:r>
+          </a:p>
+          <a:p>
+            <a:pPr marL="285750" indent="-285750">
+              <a:buFontTx/>
+              <a:buChar char="-"/>
+            </a:pPr>
+            <a:r>
+              <a:rPr lang="en-HU" dirty="0"/>
+              <a:t>Simple interface for Python postprocessor</a:t>
+            </a:r>
+          </a:p>
+          <a:p>
+            <a:pPr marL="742950" lvl="1" indent="-285750">
+              <a:buFontTx/>
+              <a:buChar char="-"/>
+            </a:pPr>
+            <a:r>
+              <a:rPr lang="en-HU" dirty="0"/>
+              <a:t>Easy access for quantization agnostic input</a:t>
+            </a:r>
+          </a:p>
+          <a:p>
+            <a:pPr marL="742950" lvl="1" indent="-285750">
+              <a:buFontTx/>
+              <a:buChar char="-"/>
+            </a:pPr>
+            <a:r>
+              <a:rPr lang="en-HU" dirty="0"/>
+              <a:t>Easy way to store processed meta</a:t>
+            </a:r>
+          </a:p>
+          <a:p>
+            <a:pPr marL="742950" lvl="1" indent="-285750">
+              <a:buFontTx/>
+              <a:buChar char="-"/>
+            </a:pPr>
+            <a:r>
+              <a:rPr lang="en-HU" dirty="0"/>
+              <a:t>More accessible for ML engineers</a:t>
+            </a:r>
+          </a:p>
+        </p:txBody>
+      </p:sp>
+      <p:sp>
+        <p:nvSpPr>
+          <p:cNvPr id="8" name="Rounded Rectangle 7">
+            <a:extLst>
+              <a:ext uri="{FF2B5EF4-FFF2-40B4-BE49-F238E27FC236}">
+                <a16:creationId xmlns:a16="http://schemas.microsoft.com/office/drawing/2014/main" id="{05DF714A-BF3B-CD2F-B854-A38B9DD17DE0}"/>
+              </a:ext>
+            </a:extLst>
+          </p:cNvPr>
+          <p:cNvSpPr/>
+          <p:nvPr/>
+        </p:nvSpPr>
+        <p:spPr>
+          <a:xfrm>
+            <a:off x="8133055" y="5160112"/>
+            <a:ext cx="2166964" cy="873610"/>
+          </a:xfrm>
+          <a:prstGeom prst="roundRect">
+            <a:avLst/>
+          </a:prstGeom>
+          <a:solidFill>
+            <a:schemeClr val="accent6">
+              <a:lumMod val="75000"/>
+            </a:schemeClr>
+          </a:solidFill>
+        </p:spPr>
+        <p:style>
+          <a:lnRef idx="2">
+            <a:schemeClr val="accent1">
+              <a:shade val="15000"/>
+            </a:schemeClr>
+          </a:lnRef>
+          <a:fillRef idx="1">
+            <a:schemeClr val="accent1"/>
+          </a:fillRef>
+          <a:effectRef idx="0">
+            <a:schemeClr val="accent1"/>
+          </a:effectRef>
+          <a:fontRef idx="minor">
+            <a:schemeClr val="lt1"/>
+          </a:fontRef>
+        </p:style>
+        <p:txBody>
+          <a:bodyPr rtlCol="0" anchor="ctr"/>
+          <a:lstStyle/>
+          <a:p>
+            <a:pPr algn="ctr"/>
+            <a:r>
+              <a:rPr lang="en-HU" b="1" dirty="0"/>
+              <a:t>Python postprocess</a:t>
+            </a:r>
+            <a:endParaRPr lang="en-HU" dirty="0"/>
+          </a:p>
+        </p:txBody>
+      </p:sp>
+      <p:sp>
+        <p:nvSpPr>
+          <p:cNvPr id="9" name="Rounded Rectangle 8">
+            <a:extLst>
+              <a:ext uri="{FF2B5EF4-FFF2-40B4-BE49-F238E27FC236}">
+                <a16:creationId xmlns:a16="http://schemas.microsoft.com/office/drawing/2014/main" id="{7946CCDA-60B2-C70A-EBA5-EF0041E70517}"/>
+              </a:ext>
+            </a:extLst>
+          </p:cNvPr>
+          <p:cNvSpPr/>
+          <p:nvPr/>
+        </p:nvSpPr>
+        <p:spPr>
+          <a:xfrm>
+            <a:off x="6433456" y="1726720"/>
+            <a:ext cx="1614097" cy="767045"/>
+          </a:xfrm>
+          <a:prstGeom prst="roundRect">
+            <a:avLst/>
+          </a:prstGeom>
+        </p:spPr>
+        <p:style>
+          <a:lnRef idx="2">
+            <a:schemeClr val="accent1">
+              <a:shade val="15000"/>
+            </a:schemeClr>
+          </a:lnRef>
+          <a:fillRef idx="1">
+            <a:schemeClr val="accent1"/>
+          </a:fillRef>
+          <a:effectRef idx="0">
+            <a:schemeClr val="accent1"/>
+          </a:effectRef>
+          <a:fontRef idx="minor">
+            <a:schemeClr val="lt1"/>
+          </a:fontRef>
+        </p:style>
+        <p:txBody>
+          <a:bodyPr rtlCol="0" anchor="ctr"/>
+          <a:lstStyle/>
+          <a:p>
+            <a:pPr algn="ctr"/>
+            <a:r>
+              <a:rPr lang="en-HU" b="1" dirty="0"/>
+              <a:t>C++ inference</a:t>
+            </a:r>
+          </a:p>
+        </p:txBody>
+      </p:sp>
+      <p:sp>
+        <p:nvSpPr>
+          <p:cNvPr id="10" name="Rounded Rectangle 9">
+            <a:extLst>
+              <a:ext uri="{FF2B5EF4-FFF2-40B4-BE49-F238E27FC236}">
+                <a16:creationId xmlns:a16="http://schemas.microsoft.com/office/drawing/2014/main" id="{20F982C9-BDF4-982C-E531-980F80287FDB}"/>
+              </a:ext>
+            </a:extLst>
+          </p:cNvPr>
+          <p:cNvSpPr/>
+          <p:nvPr/>
+        </p:nvSpPr>
+        <p:spPr>
+          <a:xfrm>
+            <a:off x="8409489" y="1725341"/>
+            <a:ext cx="1614096" cy="767045"/>
+          </a:xfrm>
+          <a:prstGeom prst="roundRect">
+            <a:avLst/>
+          </a:prstGeom>
+        </p:spPr>
+        <p:style>
+          <a:lnRef idx="2">
+            <a:schemeClr val="accent1">
+              <a:shade val="15000"/>
+            </a:schemeClr>
+          </a:lnRef>
+          <a:fillRef idx="1">
+            <a:schemeClr val="accent1"/>
+          </a:fillRef>
+          <a:effectRef idx="0">
+            <a:schemeClr val="accent1"/>
+          </a:effectRef>
+          <a:fontRef idx="minor">
+            <a:schemeClr val="lt1"/>
+          </a:fontRef>
+        </p:style>
+        <p:txBody>
+          <a:bodyPr rtlCol="0" anchor="ctr"/>
+          <a:lstStyle/>
+          <a:p>
+            <a:pPr algn="ctr"/>
+            <a:r>
+              <a:rPr lang="en-HU" b="1" dirty="0"/>
+              <a:t>C++ postprocess</a:t>
+            </a:r>
+          </a:p>
+        </p:txBody>
+      </p:sp>
+      <p:cxnSp>
+        <p:nvCxnSpPr>
+          <p:cNvPr id="11" name="Straight Arrow Connector 10">
+            <a:extLst>
+              <a:ext uri="{FF2B5EF4-FFF2-40B4-BE49-F238E27FC236}">
+                <a16:creationId xmlns:a16="http://schemas.microsoft.com/office/drawing/2014/main" id="{0F8EDAEF-84F4-88A5-AC27-9FB3CC1954FE}"/>
+              </a:ext>
+            </a:extLst>
+          </p:cNvPr>
+          <p:cNvCxnSpPr>
+            <a:cxnSpLocks/>
+            <a:stCxn id="9" idx="3"/>
+            <a:endCxn id="10" idx="1"/>
+          </p:cNvCxnSpPr>
+          <p:nvPr/>
+        </p:nvCxnSpPr>
+        <p:spPr>
+          <a:xfrm flipV="1">
+            <a:off x="8047553" y="2108864"/>
+            <a:ext cx="361936" cy="1379"/>
+          </a:xfrm>
+          <a:prstGeom prst="straightConnector1">
+            <a:avLst/>
+          </a:prstGeom>
+          <a:ln>
+            <a:tailEnd type="triangle"/>
+          </a:ln>
+        </p:spPr>
+        <p:style>
+          <a:lnRef idx="3">
+            <a:schemeClr val="dk1"/>
+          </a:lnRef>
+          <a:fillRef idx="0">
+            <a:schemeClr val="dk1"/>
+          </a:fillRef>
+          <a:effectRef idx="2">
+            <a:schemeClr val="dk1"/>
+          </a:effectRef>
+          <a:fontRef idx="minor">
+            <a:schemeClr val="tx1"/>
+          </a:fontRef>
+        </p:style>
+      </p:cxnSp>
+      <p:sp>
+        <p:nvSpPr>
+          <p:cNvPr id="12" name="Rounded Rectangle 11">
+            <a:extLst>
+              <a:ext uri="{FF2B5EF4-FFF2-40B4-BE49-F238E27FC236}">
+                <a16:creationId xmlns:a16="http://schemas.microsoft.com/office/drawing/2014/main" id="{BCC3944C-C455-FDC9-03ED-212E3230F5B9}"/>
+              </a:ext>
+            </a:extLst>
+          </p:cNvPr>
+          <p:cNvSpPr/>
+          <p:nvPr/>
+        </p:nvSpPr>
+        <p:spPr>
+          <a:xfrm>
+            <a:off x="10385522" y="1725340"/>
+            <a:ext cx="1614097" cy="767045"/>
+          </a:xfrm>
+          <a:prstGeom prst="roundRect">
+            <a:avLst/>
+          </a:prstGeom>
+        </p:spPr>
+        <p:style>
+          <a:lnRef idx="2">
+            <a:schemeClr val="accent1">
+              <a:shade val="15000"/>
+            </a:schemeClr>
+          </a:lnRef>
+          <a:fillRef idx="1">
+            <a:schemeClr val="accent1"/>
+          </a:fillRef>
+          <a:effectRef idx="0">
+            <a:schemeClr val="accent1"/>
+          </a:effectRef>
+          <a:fontRef idx="minor">
+            <a:schemeClr val="lt1"/>
+          </a:fontRef>
+        </p:style>
+        <p:txBody>
+          <a:bodyPr rtlCol="0" anchor="ctr"/>
+          <a:lstStyle/>
+          <a:p>
+            <a:pPr algn="ctr"/>
+            <a:r>
+              <a:rPr lang="en-HU" b="1" dirty="0"/>
+              <a:t>Inferred Meta</a:t>
+            </a:r>
+          </a:p>
+        </p:txBody>
+      </p:sp>
+      <p:cxnSp>
+        <p:nvCxnSpPr>
+          <p:cNvPr id="13" name="Straight Arrow Connector 12">
+            <a:extLst>
+              <a:ext uri="{FF2B5EF4-FFF2-40B4-BE49-F238E27FC236}">
+                <a16:creationId xmlns:a16="http://schemas.microsoft.com/office/drawing/2014/main" id="{8AD94892-7335-E660-5894-F18F18D25E9E}"/>
+              </a:ext>
+            </a:extLst>
+          </p:cNvPr>
+          <p:cNvCxnSpPr>
+            <a:cxnSpLocks/>
+            <a:stCxn id="10" idx="3"/>
+            <a:endCxn id="12" idx="1"/>
+          </p:cNvCxnSpPr>
+          <p:nvPr/>
+        </p:nvCxnSpPr>
+        <p:spPr>
+          <a:xfrm flipV="1">
+            <a:off x="10023585" y="2108863"/>
+            <a:ext cx="361937" cy="1"/>
+          </a:xfrm>
+          <a:prstGeom prst="straightConnector1">
+            <a:avLst/>
+          </a:prstGeom>
+          <a:ln>
+            <a:tailEnd type="triangle"/>
+          </a:ln>
+        </p:spPr>
+        <p:style>
+          <a:lnRef idx="3">
+            <a:schemeClr val="dk1"/>
+          </a:lnRef>
+          <a:fillRef idx="0">
+            <a:schemeClr val="dk1"/>
+          </a:fillRef>
+          <a:effectRef idx="2">
+            <a:schemeClr val="dk1"/>
+          </a:effectRef>
+          <a:fontRef idx="minor">
+            <a:schemeClr val="tx1"/>
+          </a:fontRef>
+        </p:style>
+      </p:cxnSp>
+      <p:sp>
+        <p:nvSpPr>
+          <p:cNvPr id="14" name="Rounded Rectangle 13">
+            <a:extLst>
+              <a:ext uri="{FF2B5EF4-FFF2-40B4-BE49-F238E27FC236}">
+                <a16:creationId xmlns:a16="http://schemas.microsoft.com/office/drawing/2014/main" id="{0805935E-EE51-9D10-9D4C-F7A695F4A6C5}"/>
+              </a:ext>
+            </a:extLst>
+          </p:cNvPr>
+          <p:cNvSpPr/>
+          <p:nvPr/>
+        </p:nvSpPr>
+        <p:spPr>
+          <a:xfrm>
+            <a:off x="6433456" y="3903442"/>
+            <a:ext cx="1614097" cy="767045"/>
+          </a:xfrm>
+          <a:prstGeom prst="roundRect">
+            <a:avLst/>
+          </a:prstGeom>
+        </p:spPr>
+        <p:style>
+          <a:lnRef idx="2">
+            <a:schemeClr val="accent1">
+              <a:shade val="15000"/>
+            </a:schemeClr>
+          </a:lnRef>
+          <a:fillRef idx="1">
+            <a:schemeClr val="accent1"/>
+          </a:fillRef>
+          <a:effectRef idx="0">
+            <a:schemeClr val="accent1"/>
+          </a:effectRef>
+          <a:fontRef idx="minor">
+            <a:schemeClr val="lt1"/>
+          </a:fontRef>
+        </p:style>
+        <p:txBody>
+          <a:bodyPr rtlCol="0" anchor="ctr"/>
+          <a:lstStyle/>
+          <a:p>
+            <a:pPr algn="ctr"/>
+            <a:r>
+              <a:rPr lang="en-HU" b="1" dirty="0"/>
+              <a:t>C++ inference</a:t>
+            </a:r>
+          </a:p>
+        </p:txBody>
+      </p:sp>
+      <p:sp>
+        <p:nvSpPr>
+          <p:cNvPr id="15" name="Rounded Rectangle 14">
+            <a:extLst>
+              <a:ext uri="{FF2B5EF4-FFF2-40B4-BE49-F238E27FC236}">
+                <a16:creationId xmlns:a16="http://schemas.microsoft.com/office/drawing/2014/main" id="{F5488A8E-F3DA-795C-FCB6-FB98D0DF1EDB}"/>
+              </a:ext>
+            </a:extLst>
+          </p:cNvPr>
+          <p:cNvSpPr/>
+          <p:nvPr/>
+        </p:nvSpPr>
+        <p:spPr>
+          <a:xfrm>
+            <a:off x="10385522" y="3902062"/>
+            <a:ext cx="1614097" cy="767045"/>
+          </a:xfrm>
+          <a:prstGeom prst="roundRect">
+            <a:avLst/>
+          </a:prstGeom>
+        </p:spPr>
+        <p:style>
+          <a:lnRef idx="2">
+            <a:schemeClr val="accent1">
+              <a:shade val="15000"/>
+            </a:schemeClr>
+          </a:lnRef>
+          <a:fillRef idx="1">
+            <a:schemeClr val="accent1"/>
+          </a:fillRef>
+          <a:effectRef idx="0">
+            <a:schemeClr val="accent1"/>
+          </a:effectRef>
+          <a:fontRef idx="minor">
+            <a:schemeClr val="lt1"/>
+          </a:fontRef>
+        </p:style>
+        <p:txBody>
+          <a:bodyPr rtlCol="0" anchor="ctr"/>
+          <a:lstStyle/>
+          <a:p>
+            <a:pPr algn="ctr"/>
+            <a:r>
+              <a:rPr lang="en-HU" b="1" dirty="0"/>
+              <a:t>Inferred Meta</a:t>
+            </a:r>
+          </a:p>
+        </p:txBody>
+      </p:sp>
+      <p:cxnSp>
+        <p:nvCxnSpPr>
+          <p:cNvPr id="16" name="Elbow Connector 15">
+            <a:extLst>
+              <a:ext uri="{FF2B5EF4-FFF2-40B4-BE49-F238E27FC236}">
+                <a16:creationId xmlns:a16="http://schemas.microsoft.com/office/drawing/2014/main" id="{A8869D92-5168-A27A-3E9E-AC1A6CBAB459}"/>
+              </a:ext>
+            </a:extLst>
+          </p:cNvPr>
+          <p:cNvCxnSpPr>
+            <a:stCxn id="14" idx="2"/>
+            <a:endCxn id="8" idx="1"/>
+          </p:cNvCxnSpPr>
+          <p:nvPr/>
+        </p:nvCxnSpPr>
+        <p:spPr>
+          <a:xfrm rot="16200000" flipH="1">
+            <a:off x="7223565" y="4687427"/>
+            <a:ext cx="926430" cy="892550"/>
+          </a:xfrm>
+          <a:prstGeom prst="bentConnector2">
+            <a:avLst/>
+          </a:prstGeom>
+          <a:ln>
+            <a:tailEnd type="triangle"/>
+          </a:ln>
+        </p:spPr>
+        <p:style>
+          <a:lnRef idx="2">
+            <a:schemeClr val="accent1"/>
+          </a:lnRef>
+          <a:fillRef idx="0">
+            <a:schemeClr val="accent1"/>
+          </a:fillRef>
+          <a:effectRef idx="1">
+            <a:schemeClr val="accent1"/>
+          </a:effectRef>
+          <a:fontRef idx="minor">
+            <a:schemeClr val="tx1"/>
+          </a:fontRef>
+        </p:style>
+      </p:cxnSp>
+      <p:cxnSp>
+        <p:nvCxnSpPr>
+          <p:cNvPr id="17" name="Elbow Connector 16">
+            <a:extLst>
+              <a:ext uri="{FF2B5EF4-FFF2-40B4-BE49-F238E27FC236}">
+                <a16:creationId xmlns:a16="http://schemas.microsoft.com/office/drawing/2014/main" id="{BBC9AD5B-64B4-F27B-1255-042BD059A7A6}"/>
+              </a:ext>
+            </a:extLst>
+          </p:cNvPr>
+          <p:cNvCxnSpPr>
+            <a:stCxn id="8" idx="3"/>
+            <a:endCxn id="15" idx="2"/>
+          </p:cNvCxnSpPr>
+          <p:nvPr/>
+        </p:nvCxnSpPr>
+        <p:spPr>
+          <a:xfrm flipV="1">
+            <a:off x="10300019" y="4669107"/>
+            <a:ext cx="892552" cy="927810"/>
+          </a:xfrm>
+          <a:prstGeom prst="bentConnector2">
+            <a:avLst/>
+          </a:prstGeom>
+          <a:ln>
+            <a:tailEnd type="triangle"/>
+          </a:ln>
+        </p:spPr>
+        <p:style>
+          <a:lnRef idx="2">
+            <a:schemeClr val="accent1"/>
+          </a:lnRef>
+          <a:fillRef idx="0">
+            <a:schemeClr val="accent1"/>
+          </a:fillRef>
+          <a:effectRef idx="1">
+            <a:schemeClr val="accent1"/>
+          </a:effectRef>
+          <a:fontRef idx="minor">
+            <a:schemeClr val="tx1"/>
+          </a:fontRef>
+        </p:style>
+      </p:cxnSp>
+      <p:sp>
+        <p:nvSpPr>
+          <p:cNvPr id="18" name="TextBox 17">
+            <a:extLst>
+              <a:ext uri="{FF2B5EF4-FFF2-40B4-BE49-F238E27FC236}">
+                <a16:creationId xmlns:a16="http://schemas.microsoft.com/office/drawing/2014/main" id="{5D6E16A7-5F06-34B4-6DC9-779EB397DF22}"/>
+              </a:ext>
+            </a:extLst>
+          </p:cNvPr>
+          <p:cNvSpPr txBox="1"/>
+          <p:nvPr/>
+        </p:nvSpPr>
+        <p:spPr>
+          <a:xfrm>
+            <a:off x="6856018" y="1089124"/>
+            <a:ext cx="4981172" cy="369332"/>
+          </a:xfrm>
+          <a:prstGeom prst="rect">
+            <a:avLst/>
+          </a:prstGeom>
+          <a:noFill/>
+        </p:spPr>
+        <p:txBody>
+          <a:bodyPr wrap="none" rtlCol="0">
+            <a:spAutoFit/>
+          </a:bodyPr>
+          <a:lstStyle/>
+          <a:p>
+            <a:r>
+              <a:rPr lang="en-HU" b="1" dirty="0"/>
+              <a:t>Simple method – with fast C++ postprocessors</a:t>
+            </a:r>
+          </a:p>
+        </p:txBody>
+      </p:sp>
+      <p:sp>
+        <p:nvSpPr>
+          <p:cNvPr id="19" name="TextBox 18">
+            <a:extLst>
+              <a:ext uri="{FF2B5EF4-FFF2-40B4-BE49-F238E27FC236}">
+                <a16:creationId xmlns:a16="http://schemas.microsoft.com/office/drawing/2014/main" id="{59EB1ECD-3AE0-D1A4-4C58-EA566164FCC1}"/>
+              </a:ext>
+            </a:extLst>
+          </p:cNvPr>
+          <p:cNvSpPr txBox="1"/>
+          <p:nvPr/>
+        </p:nvSpPr>
+        <p:spPr>
+          <a:xfrm>
+            <a:off x="8094915" y="3280591"/>
+            <a:ext cx="2503378" cy="369332"/>
+          </a:xfrm>
+          <a:prstGeom prst="rect">
+            <a:avLst/>
+          </a:prstGeom>
+          <a:noFill/>
+        </p:spPr>
+        <p:txBody>
+          <a:bodyPr wrap="none" rtlCol="0">
+            <a:spAutoFit/>
+          </a:bodyPr>
+          <a:lstStyle/>
+          <a:p>
+            <a:r>
+              <a:rPr lang="en-HU" b="1" dirty="0"/>
+              <a:t>Python-based method</a:t>
+            </a:r>
+          </a:p>
+        </p:txBody>
+      </p:sp>
+    </p:spTree>
+    <p:extLst>
+      <p:ext uri="{BB962C8B-B14F-4D97-AF65-F5344CB8AC3E}">
+        <p14:creationId xmlns:p14="http://schemas.microsoft.com/office/powerpoint/2010/main" val="2023222543"/>
       </p:ext>
     </p:extLst>
   </p:cSld>

</xml_diff>